<commit_message>
Upgrade 7-slide presentation deck to high-end luxury design matching AI_Agricultural_Disaster_Shorts_Studio
</commit_message>
<xml_diff>
--- a/GBAN_AI_숏폼_스튜디오_발표자료_7장.pptx
+++ b/GBAN_AI_숏폼_스튜디오_발표자료_7장.pptx
@@ -3109,7 +3109,7 @@
             <a:avLst/>
           </a:prstGeom>
           <a:solidFill>
-            <a:srgbClr val="F8F6F0"/>
+            <a:srgbClr val="13221B"/>
           </a:solidFill>
           <a:ln>
             <a:noFill/>
@@ -3152,10 +3152,12 @@
             <a:avLst/>
           </a:prstGeom>
           <a:solidFill>
-            <a:srgbClr val="1A2E26"/>
+            <a:srgbClr val="1B2E25"/>
           </a:solidFill>
-          <a:ln>
-            <a:noFill/>
+          <a:ln w="19050">
+            <a:solidFill>
+              <a:srgbClr val="264034"/>
+            </a:solidFill>
           </a:ln>
         </p:spPr>
         <p:style>
@@ -3182,14 +3184,59 @@
       </p:sp>
       <p:sp>
         <p:nvSpPr>
-          <p:cNvPr id="4" name="TextBox 3"/>
+          <p:cNvPr id="4" name="Rounded Rectangle 3"/>
+          <p:cNvSpPr/>
+          <p:nvPr/>
+        </p:nvSpPr>
+        <p:spPr>
+          <a:xfrm>
+            <a:off x="1188720" y="1188720"/>
+            <a:ext cx="6858000" cy="411480"/>
+          </a:xfrm>
+          <a:prstGeom prst="roundRect">
+            <a:avLst/>
+          </a:prstGeom>
+          <a:solidFill>
+            <a:srgbClr val="1E4030"/>
+          </a:solidFill>
+          <a:ln w="12700">
+            <a:solidFill>
+              <a:srgbClr val="10B981"/>
+            </a:solidFill>
+          </a:ln>
+        </p:spPr>
+        <p:style>
+          <a:lnRef idx="1">
+            <a:schemeClr val="accent1"/>
+          </a:lnRef>
+          <a:fillRef idx="3">
+            <a:schemeClr val="accent1"/>
+          </a:fillRef>
+          <a:effectRef idx="2">
+            <a:schemeClr val="accent1"/>
+          </a:effectRef>
+          <a:fontRef idx="minor">
+            <a:schemeClr val="lt1"/>
+          </a:fontRef>
+        </p:style>
+        <p:txBody>
+          <a:bodyPr rtlCol="0" anchor="ctr"/>
+          <a:lstStyle/>
+          <a:p>
+            <a:pPr algn="ctr"/>
+          </a:p>
+        </p:txBody>
+      </p:sp>
+      <p:sp>
+        <p:nvSpPr>
+          <p:cNvPr id="5" name="TextBox 4"/>
           <p:cNvSpPr txBox="1"/>
           <p:nvPr/>
         </p:nvSpPr>
         <p:spPr>
           <a:xfrm>
-            <a:off x="1188720" y="1188720"/>
-            <a:ext cx="9784080" cy="457200"/>
+            <a:off x="1280160" y="1207008"/>
+            <a:ext cx="6675120" cy="365760"/>
           </a:xfrm>
           <a:prstGeom prst="rect">
             <a:avLst/>
@@ -3203,28 +3250,28 @@
           <a:lstStyle/>
           <a:p>
             <a:pPr>
-              <a:defRPr sz="1600" b="1">
-                <a:solidFill>
-                  <a:srgbClr val="10B981"/>
+              <a:defRPr sz="1400" b="1">
+                <a:solidFill>
+                  <a:srgbClr val="A7F3D0"/>
                 </a:solidFill>
                 <a:latin typeface="Malgun Gothic"/>
               </a:defRPr>
             </a:pPr>
             <a:r>
-              <a:t>경상북도농업기술원  |  AI 데이터 전문인재 양성 프로젝트 발표</a:t>
-            </a:r>
-          </a:p>
-        </p:txBody>
-      </p:sp>
-      <p:sp>
-        <p:nvSpPr>
-          <p:cNvPr id="5" name="TextBox 4"/>
+              <a:t>경상북도농업기술원 AI 데이터 전문인재 양성 프로젝트 발표</a:t>
+            </a:r>
+          </a:p>
+        </p:txBody>
+      </p:sp>
+      <p:sp>
+        <p:nvSpPr>
+          <p:cNvPr id="6" name="TextBox 5"/>
           <p:cNvSpPr txBox="1"/>
           <p:nvPr/>
         </p:nvSpPr>
         <p:spPr>
           <a:xfrm>
-            <a:off x="1188720" y="1737360"/>
+            <a:off x="1188720" y="1828800"/>
             <a:ext cx="9784080" cy="1645920"/>
           </a:xfrm>
           <a:prstGeom prst="rect">
@@ -3258,13 +3305,13 @@
       </p:sp>
       <p:sp>
         <p:nvSpPr>
-          <p:cNvPr id="6" name="TextBox 5"/>
+          <p:cNvPr id="7" name="TextBox 6"/>
           <p:cNvSpPr txBox="1"/>
           <p:nvPr/>
         </p:nvSpPr>
         <p:spPr>
           <a:xfrm>
-            <a:off x="1188720" y="3566160"/>
+            <a:off x="1188720" y="3657600"/>
             <a:ext cx="9784080" cy="731520"/>
           </a:xfrm>
           <a:prstGeom prst="rect">
@@ -3281,27 +3328,72 @@
             <a:pPr>
               <a:defRPr sz="1700">
                 <a:solidFill>
-                  <a:srgbClr val="C8E1D2"/>
+                  <a:srgbClr val="A7F3D0"/>
                 </a:solidFill>
                 <a:latin typeface="Malgun Gothic"/>
               </a:defRPr>
             </a:pPr>
             <a:r>
-              <a:t>부제: 기존 텍스트 긴급문자의 한계를 극복하는 고가독성 모바일 재해 속보 제작 플랫폼</a:t>
-            </a:r>
-          </a:p>
-        </p:txBody>
-      </p:sp>
-      <p:sp>
-        <p:nvSpPr>
-          <p:cNvPr id="7" name="TextBox 6"/>
+              <a:t>부제: 기존 텍스트 문자의 한계를 극복하는 고가독성 재해 대응 속보 제작 플랫폼</a:t>
+            </a:r>
+          </a:p>
+        </p:txBody>
+      </p:sp>
+      <p:sp>
+        <p:nvSpPr>
+          <p:cNvPr id="8" name="Rounded Rectangle 7"/>
+          <p:cNvSpPr/>
+          <p:nvPr/>
+        </p:nvSpPr>
+        <p:spPr>
+          <a:xfrm>
+            <a:off x="1188720" y="4663440"/>
+            <a:ext cx="9814255" cy="1005840"/>
+          </a:xfrm>
+          <a:prstGeom prst="roundRect">
+            <a:avLst/>
+          </a:prstGeom>
+          <a:solidFill>
+            <a:srgbClr val="13221B"/>
+          </a:solidFill>
+          <a:ln w="12700">
+            <a:solidFill>
+              <a:srgbClr val="284B3C"/>
+            </a:solidFill>
+          </a:ln>
+        </p:spPr>
+        <p:style>
+          <a:lnRef idx="1">
+            <a:schemeClr val="accent1"/>
+          </a:lnRef>
+          <a:fillRef idx="3">
+            <a:schemeClr val="accent1"/>
+          </a:fillRef>
+          <a:effectRef idx="2">
+            <a:schemeClr val="accent1"/>
+          </a:effectRef>
+          <a:fontRef idx="minor">
+            <a:schemeClr val="lt1"/>
+          </a:fontRef>
+        </p:style>
+        <p:txBody>
+          <a:bodyPr rtlCol="0" anchor="ctr"/>
+          <a:lstStyle/>
+          <a:p>
+            <a:pPr algn="ctr"/>
+          </a:p>
+        </p:txBody>
+      </p:sp>
+      <p:sp>
+        <p:nvSpPr>
+          <p:cNvPr id="9" name="TextBox 8"/>
           <p:cNvSpPr txBox="1"/>
           <p:nvPr/>
         </p:nvSpPr>
         <p:spPr>
           <a:xfrm>
-            <a:off x="1188720" y="4754880"/>
-            <a:ext cx="9784080" cy="914400"/>
+            <a:off x="1371600" y="4800600"/>
+            <a:ext cx="9418320" cy="731520"/>
           </a:xfrm>
           <a:prstGeom prst="rect">
             <a:avLst/>
@@ -3309,13 +3401,13 @@
           <a:noFill/>
         </p:spPr>
         <p:txBody>
-          <a:bodyPr wrap="none">
+          <a:bodyPr wrap="square">
             <a:spAutoFit/>
           </a:bodyPr>
           <a:lstStyle/>
           <a:p>
             <a:pPr>
-              <a:defRPr sz="1700" b="1">
+              <a:defRPr sz="1600" b="1">
                 <a:solidFill>
                   <a:srgbClr val="FFFFFF"/>
                 </a:solidFill>
@@ -3323,7 +3415,11 @@
               </a:defRPr>
             </a:pPr>
             <a:r>
-              <a:t>발표자: 팀 3 (이동은, 김영아, 이미향)   |   접속 URL: https://gban-shorts.onrender.com</a:t>
+              <a:t>• 발표팀: 팀 3 (이동은, 김영아, 이미향)</a:t>
+            </a:r>
+            <a:br/>
+            <a:r>
+              <a:t>• 라이브 서비스 주소: https://gban-shorts.onrender.com</a:t>
             </a:r>
           </a:p>
         </p:txBody>
@@ -3361,7 +3457,7 @@
             <a:avLst/>
           </a:prstGeom>
           <a:solidFill>
-            <a:srgbClr val="F8F6F0"/>
+            <a:srgbClr val="F6F8F5"/>
           </a:solidFill>
           <a:ln>
             <a:noFill/>
@@ -3391,14 +3487,57 @@
       </p:sp>
       <p:sp>
         <p:nvSpPr>
-          <p:cNvPr id="3" name="TextBox 2"/>
+          <p:cNvPr id="3" name="Rounded Rectangle 2"/>
+          <p:cNvSpPr/>
+          <p:nvPr/>
+        </p:nvSpPr>
+        <p:spPr>
+          <a:xfrm>
+            <a:off x="731520" y="365760"/>
+            <a:ext cx="109728" cy="822960"/>
+          </a:xfrm>
+          <a:prstGeom prst="roundRect">
+            <a:avLst/>
+          </a:prstGeom>
+          <a:solidFill>
+            <a:srgbClr val="10B981"/>
+          </a:solidFill>
+          <a:ln>
+            <a:noFill/>
+          </a:ln>
+        </p:spPr>
+        <p:style>
+          <a:lnRef idx="1">
+            <a:schemeClr val="accent1"/>
+          </a:lnRef>
+          <a:fillRef idx="3">
+            <a:schemeClr val="accent1"/>
+          </a:fillRef>
+          <a:effectRef idx="2">
+            <a:schemeClr val="accent1"/>
+          </a:effectRef>
+          <a:fontRef idx="minor">
+            <a:schemeClr val="lt1"/>
+          </a:fontRef>
+        </p:style>
+        <p:txBody>
+          <a:bodyPr rtlCol="0" anchor="ctr"/>
+          <a:lstStyle/>
+          <a:p>
+            <a:pPr algn="ctr"/>
+          </a:p>
+        </p:txBody>
+      </p:sp>
+      <p:sp>
+        <p:nvSpPr>
+          <p:cNvPr id="4" name="TextBox 3"/>
           <p:cNvSpPr txBox="1"/>
           <p:nvPr/>
         </p:nvSpPr>
         <p:spPr>
           <a:xfrm>
-            <a:off x="731520" y="365760"/>
-            <a:ext cx="1828800" cy="365760"/>
+            <a:off x="960120" y="320040"/>
+            <a:ext cx="10424160" cy="320040"/>
           </a:xfrm>
           <a:prstGeom prst="rect">
             <a:avLst/>
@@ -3412,7 +3551,7 @@
           <a:lstStyle/>
           <a:p>
             <a:pPr>
-              <a:defRPr sz="1400" b="1">
+              <a:defRPr sz="1300" b="1">
                 <a:solidFill>
                   <a:srgbClr val="10B981"/>
                 </a:solidFill>
@@ -3420,43 +3559,7 @@
               </a:defRPr>
             </a:pPr>
             <a:r>
-              <a:t>SLIDE 02</a:t>
-            </a:r>
-          </a:p>
-        </p:txBody>
-      </p:sp>
-      <p:sp>
-        <p:nvSpPr>
-          <p:cNvPr id="4" name="TextBox 3"/>
-          <p:cNvSpPr txBox="1"/>
-          <p:nvPr/>
-        </p:nvSpPr>
-        <p:spPr>
-          <a:xfrm>
-            <a:off x="1828800" y="365760"/>
-            <a:ext cx="9601200" cy="365760"/>
-          </a:xfrm>
-          <a:prstGeom prst="rect">
-            <a:avLst/>
-          </a:prstGeom>
-          <a:noFill/>
-        </p:spPr>
-        <p:txBody>
-          <a:bodyPr wrap="none">
-            <a:spAutoFit/>
-          </a:bodyPr>
-          <a:lstStyle/>
-          <a:p>
-            <a:pPr>
-              <a:defRPr sz="1300" b="1">
-                <a:solidFill>
-                  <a:srgbClr val="5A665B"/>
-                </a:solidFill>
-                <a:latin typeface="Malgun Gothic"/>
-              </a:defRPr>
-            </a:pPr>
-            <a:r>
-              <a:t>|  BACKGROUND &amp; PROBLEM</a:t>
+              <a:t>SLIDE 02  |  BACKGROUND &amp; PROBLEM</a:t>
             </a:r>
           </a:p>
         </p:txBody>
@@ -3469,8 +3572,8 @@
         </p:nvSpPr>
         <p:spPr>
           <a:xfrm>
-            <a:off x="731520" y="685800"/>
-            <a:ext cx="10698480" cy="731520"/>
+            <a:off x="960120" y="621792"/>
+            <a:ext cx="10424160" cy="640080"/>
           </a:xfrm>
           <a:prstGeom prst="rect">
             <a:avLst/>
@@ -3484,9 +3587,9 @@
           <a:lstStyle/>
           <a:p>
             <a:pPr>
-              <a:defRPr sz="2500" b="1">
-                <a:solidFill>
-                  <a:srgbClr val="1A2E26"/>
+              <a:defRPr sz="2400" b="1">
+                <a:solidFill>
+                  <a:srgbClr val="141E18"/>
                 </a:solidFill>
                 <a:latin typeface="Malgun Gothic"/>
               </a:defRPr>
@@ -3505,8 +3608,8 @@
         </p:nvSpPr>
         <p:spPr>
           <a:xfrm>
-            <a:off x="731520" y="1645920"/>
-            <a:ext cx="5212080" cy="4572000"/>
+            <a:off x="731520" y="1463040"/>
+            <a:ext cx="5212080" cy="4754880"/>
           </a:xfrm>
           <a:prstGeom prst="roundRect">
             <a:avLst/>
@@ -3516,7 +3619,7 @@
           </a:solidFill>
           <a:ln w="19050">
             <a:solidFill>
-              <a:srgbClr val="E6E1D5"/>
+              <a:srgbClr val="FECACA"/>
             </a:solidFill>
           </a:ln>
         </p:spPr>
@@ -3544,14 +3647,95 @@
       </p:sp>
       <p:sp>
         <p:nvSpPr>
-          <p:cNvPr id="7" name="TextBox 6"/>
+          <p:cNvPr id="7" name="Rounded Rectangle 6"/>
+          <p:cNvSpPr/>
+          <p:nvPr/>
+        </p:nvSpPr>
+        <p:spPr>
+          <a:xfrm>
+            <a:off x="1005840" y="1737360"/>
+            <a:ext cx="4663440" cy="502920"/>
+          </a:xfrm>
+          <a:prstGeom prst="roundRect">
+            <a:avLst/>
+          </a:prstGeom>
+          <a:solidFill>
+            <a:srgbClr val="FFF1F2"/>
+          </a:solidFill>
+          <a:ln>
+            <a:solidFill>
+              <a:srgbClr val="E11D48"/>
+            </a:solidFill>
+          </a:ln>
+        </p:spPr>
+        <p:style>
+          <a:lnRef idx="1">
+            <a:schemeClr val="accent1"/>
+          </a:lnRef>
+          <a:fillRef idx="3">
+            <a:schemeClr val="accent1"/>
+          </a:fillRef>
+          <a:effectRef idx="2">
+            <a:schemeClr val="accent1"/>
+          </a:effectRef>
+          <a:fontRef idx="minor">
+            <a:schemeClr val="lt1"/>
+          </a:fontRef>
+        </p:style>
+        <p:txBody>
+          <a:bodyPr rtlCol="0" anchor="ctr"/>
+          <a:lstStyle/>
+          <a:p>
+            <a:pPr algn="ctr"/>
+          </a:p>
+        </p:txBody>
+      </p:sp>
+      <p:sp>
+        <p:nvSpPr>
+          <p:cNvPr id="8" name="TextBox 7"/>
           <p:cNvSpPr txBox="1"/>
           <p:nvPr/>
         </p:nvSpPr>
         <p:spPr>
           <a:xfrm>
-            <a:off x="1005840" y="1920240"/>
-            <a:ext cx="4663440" cy="4023360"/>
+            <a:off x="1097280" y="1783080"/>
+            <a:ext cx="4480560" cy="411480"/>
+          </a:xfrm>
+          <a:prstGeom prst="rect">
+            <a:avLst/>
+          </a:prstGeom>
+          <a:noFill/>
+        </p:spPr>
+        <p:txBody>
+          <a:bodyPr wrap="none">
+            <a:spAutoFit/>
+          </a:bodyPr>
+          <a:lstStyle/>
+          <a:p>
+            <a:pPr>
+              <a:defRPr sz="1700" b="1">
+                <a:solidFill>
+                  <a:srgbClr val="E11D48"/>
+                </a:solidFill>
+                <a:latin typeface="Malgun Gothic"/>
+              </a:defRPr>
+            </a:pPr>
+            <a:r>
+              <a:t>🚨 현장 긴급 재난문자(LMS)의 3대 한계</a:t>
+            </a:r>
+          </a:p>
+        </p:txBody>
+      </p:sp>
+      <p:sp>
+        <p:nvSpPr>
+          <p:cNvPr id="9" name="TextBox 8"/>
+          <p:cNvSpPr txBox="1"/>
+          <p:nvPr/>
+        </p:nvSpPr>
+        <p:spPr>
+          <a:xfrm>
+            <a:off x="1005840" y="2377440"/>
+            <a:ext cx="4663440" cy="3657600"/>
           </a:xfrm>
           <a:prstGeom prst="rect">
             <a:avLst/>
@@ -3565,77 +3749,64 @@
           <a:lstStyle/>
           <a:p>
             <a:pPr>
-              <a:defRPr sz="1900" b="1">
-                <a:solidFill>
-                  <a:srgbClr val="DC2626"/>
+              <a:spcAft>
+                <a:spcPts val="1400"/>
+              </a:spcAft>
+              <a:defRPr sz="1400">
+                <a:solidFill>
+                  <a:srgbClr val="141E18"/>
                 </a:solidFill>
                 <a:latin typeface="Malgun Gothic"/>
               </a:defRPr>
             </a:pPr>
             <a:r>
-              <a:t>🚨 현장 재난문자(LMS)의 3대 문제점</a:t>
+              <a:t>1. 가독성 저하: 장문의 텍스트 위주 공지로 농가의 정보 이탈률 극심</a:t>
             </a:r>
           </a:p>
           <a:p>
             <a:pPr>
-              <a:spcBef>
+              <a:spcAft>
                 <a:spcPts val="1400"/>
-              </a:spcBef>
+              </a:spcAft>
               <a:defRPr sz="1400">
                 <a:solidFill>
-                  <a:srgbClr val="1E261F"/>
+                  <a:srgbClr val="141E18"/>
                 </a:solidFill>
                 <a:latin typeface="Malgun Gothic"/>
               </a:defRPr>
             </a:pPr>
             <a:r>
-              <a:t>1. 가독성 저하: 장문의 텍스트 위주 공지로 농가의 높은 정보 이탈률 발생</a:t>
+              <a:t>2. 고령 농업인 취약: 시각적/청각적 직관성 부족으로 긴급 행동요령 전달 실패</a:t>
             </a:r>
           </a:p>
           <a:p>
             <a:pPr>
-              <a:spcBef>
+              <a:spcAft>
                 <a:spcPts val="1400"/>
-              </a:spcBef>
+              </a:spcAft>
               <a:defRPr sz="1400">
                 <a:solidFill>
-                  <a:srgbClr val="1E261F"/>
+                  <a:srgbClr val="141E18"/>
                 </a:solidFill>
                 <a:latin typeface="Malgun Gothic"/>
               </a:defRPr>
             </a:pPr>
             <a:r>
-              <a:t>2. 고령 농업인 취약: 시각적/청각적 직관성 부족으로 긴급 대응 실패</a:t>
-            </a:r>
-          </a:p>
-          <a:p>
-            <a:pPr>
-              <a:spcBef>
-                <a:spcPts val="1400"/>
-              </a:spcBef>
-              <a:defRPr sz="1400">
-                <a:solidFill>
-                  <a:srgbClr val="1E261F"/>
-                </a:solidFill>
-                <a:latin typeface="Malgun Gothic"/>
-              </a:defRPr>
-            </a:pPr>
-            <a:r>
-              <a:t>3. 제작 지연: 담당 공무원의 반복적인 공지문성 포맷팅 및 영상 편집 기술 부재</a:t>
-            </a:r>
-          </a:p>
-        </p:txBody>
-      </p:sp>
-      <p:sp>
-        <p:nvSpPr>
-          <p:cNvPr id="8" name="Rounded Rectangle 7"/>
+              <a:t>3. 제작 지연: 담당 공무원의 반복적인 공지글 작성 및 동영상 편집 기술 부재</a:t>
+            </a:r>
+          </a:p>
+        </p:txBody>
+      </p:sp>
+      <p:sp>
+        <p:nvSpPr>
+          <p:cNvPr id="10" name="Rounded Rectangle 9"/>
           <p:cNvSpPr/>
           <p:nvPr/>
         </p:nvSpPr>
         <p:spPr>
           <a:xfrm>
-            <a:off x="6217920" y="1645920"/>
-            <a:ext cx="5212080" cy="4572000"/>
+            <a:off x="6248095" y="1463040"/>
+            <a:ext cx="5212080" cy="4754880"/>
           </a:xfrm>
           <a:prstGeom prst="roundRect">
             <a:avLst/>
@@ -3673,14 +3844,95 @@
       </p:sp>
       <p:sp>
         <p:nvSpPr>
-          <p:cNvPr id="9" name="TextBox 8"/>
+          <p:cNvPr id="11" name="Rounded Rectangle 10"/>
+          <p:cNvSpPr/>
+          <p:nvPr/>
+        </p:nvSpPr>
+        <p:spPr>
+          <a:xfrm>
+            <a:off x="6522415" y="1737360"/>
+            <a:ext cx="4663440" cy="502920"/>
+          </a:xfrm>
+          <a:prstGeom prst="roundRect">
+            <a:avLst/>
+          </a:prstGeom>
+          <a:solidFill>
+            <a:srgbClr val="ECFDF5"/>
+          </a:solidFill>
+          <a:ln>
+            <a:solidFill>
+              <a:srgbClr val="10B981"/>
+            </a:solidFill>
+          </a:ln>
+        </p:spPr>
+        <p:style>
+          <a:lnRef idx="1">
+            <a:schemeClr val="accent1"/>
+          </a:lnRef>
+          <a:fillRef idx="3">
+            <a:schemeClr val="accent1"/>
+          </a:fillRef>
+          <a:effectRef idx="2">
+            <a:schemeClr val="accent1"/>
+          </a:effectRef>
+          <a:fontRef idx="minor">
+            <a:schemeClr val="lt1"/>
+          </a:fontRef>
+        </p:style>
+        <p:txBody>
+          <a:bodyPr rtlCol="0" anchor="ctr"/>
+          <a:lstStyle/>
+          <a:p>
+            <a:pPr algn="ctr"/>
+          </a:p>
+        </p:txBody>
+      </p:sp>
+      <p:sp>
+        <p:nvSpPr>
+          <p:cNvPr id="12" name="TextBox 11"/>
           <p:cNvSpPr txBox="1"/>
           <p:nvPr/>
         </p:nvSpPr>
         <p:spPr>
           <a:xfrm>
-            <a:off x="6492240" y="1920240"/>
-            <a:ext cx="4663440" cy="4023360"/>
+            <a:off x="6613855" y="1783080"/>
+            <a:ext cx="4480560" cy="411480"/>
+          </a:xfrm>
+          <a:prstGeom prst="rect">
+            <a:avLst/>
+          </a:prstGeom>
+          <a:noFill/>
+        </p:spPr>
+        <p:txBody>
+          <a:bodyPr wrap="none">
+            <a:spAutoFit/>
+          </a:bodyPr>
+          <a:lstStyle/>
+          <a:p>
+            <a:pPr>
+              <a:defRPr sz="1700" b="1">
+                <a:solidFill>
+                  <a:srgbClr val="10B981"/>
+                </a:solidFill>
+                <a:latin typeface="Malgun Gothic"/>
+              </a:defRPr>
+            </a:pPr>
+            <a:r>
+              <a:t>💡 AI 숏폼 스튜디오의 혁신적 해결책</a:t>
+            </a:r>
+          </a:p>
+        </p:txBody>
+      </p:sp>
+      <p:sp>
+        <p:nvSpPr>
+          <p:cNvPr id="13" name="TextBox 12"/>
+          <p:cNvSpPr txBox="1"/>
+          <p:nvPr/>
+        </p:nvSpPr>
+        <p:spPr>
+          <a:xfrm>
+            <a:off x="6522415" y="2377440"/>
+            <a:ext cx="4663440" cy="3657600"/>
           </a:xfrm>
           <a:prstGeom prst="rect">
             <a:avLst/>
@@ -3694,57 +3946,44 @@
           <a:lstStyle/>
           <a:p>
             <a:pPr>
-              <a:defRPr sz="1900" b="1">
-                <a:solidFill>
-                  <a:srgbClr val="10B981"/>
+              <a:spcAft>
+                <a:spcPts val="1400"/>
+              </a:spcAft>
+              <a:defRPr sz="1400">
+                <a:solidFill>
+                  <a:srgbClr val="141E18"/>
                 </a:solidFill>
                 <a:latin typeface="Malgun Gothic"/>
               </a:defRPr>
             </a:pPr>
             <a:r>
-              <a:t>💡 AI 숏폼 스튜디오의 해결책</a:t>
+              <a:t>✔ 1~2분 초스피드 제작: 사진 첨부 + 문구 입력만으로 즉시 동영상 자동 생성</a:t>
             </a:r>
           </a:p>
           <a:p>
             <a:pPr>
-              <a:spcBef>
+              <a:spcAft>
                 <a:spcPts val="1400"/>
-              </a:spcBef>
+              </a:spcAft>
               <a:defRPr sz="1400">
                 <a:solidFill>
-                  <a:srgbClr val="1E261F"/>
+                  <a:srgbClr val="141E18"/>
                 </a:solidFill>
                 <a:latin typeface="Malgun Gothic"/>
               </a:defRPr>
             </a:pPr>
             <a:r>
-              <a:t>✔ 1~2분 초스피드 제작: 사진 첨부 + 문구 입력만으로 즉시 동영상 자동 생성</a:t>
+              <a:t>✔ 융합형 숏폼 포맷: 자막 + 고품질 AI 음성(TTS) + BGM이 조화된 9:16 비디오</a:t>
             </a:r>
           </a:p>
           <a:p>
             <a:pPr>
-              <a:spcBef>
+              <a:spcAft>
                 <a:spcPts val="1400"/>
-              </a:spcBef>
+              </a:spcAft>
               <a:defRPr sz="1400">
                 <a:solidFill>
-                  <a:srgbClr val="1E261F"/>
-                </a:solidFill>
-                <a:latin typeface="Malgun Gothic"/>
-              </a:defRPr>
-            </a:pPr>
-            <a:r>
-              <a:t>✔ 융합형 숏폼 포맷: 자막 + 고품질 AI 음성(TTS) + BGM이 조화된 9:16 비디오</a:t>
-            </a:r>
-          </a:p>
-          <a:p>
-            <a:pPr>
-              <a:spcBef>
-                <a:spcPts val="1400"/>
-              </a:spcBef>
-              <a:defRPr sz="1400">
-                <a:solidFill>
-                  <a:srgbClr val="1E261F"/>
+                  <a:srgbClr val="141E18"/>
                 </a:solidFill>
                 <a:latin typeface="Malgun Gothic"/>
               </a:defRPr>
@@ -3788,7 +4027,7 @@
             <a:avLst/>
           </a:prstGeom>
           <a:solidFill>
-            <a:srgbClr val="F8F6F0"/>
+            <a:srgbClr val="F6F8F5"/>
           </a:solidFill>
           <a:ln>
             <a:noFill/>
@@ -3818,14 +4057,57 @@
       </p:sp>
       <p:sp>
         <p:nvSpPr>
-          <p:cNvPr id="3" name="TextBox 2"/>
+          <p:cNvPr id="3" name="Rounded Rectangle 2"/>
+          <p:cNvSpPr/>
+          <p:nvPr/>
+        </p:nvSpPr>
+        <p:spPr>
+          <a:xfrm>
+            <a:off x="731520" y="365760"/>
+            <a:ext cx="109728" cy="822960"/>
+          </a:xfrm>
+          <a:prstGeom prst="roundRect">
+            <a:avLst/>
+          </a:prstGeom>
+          <a:solidFill>
+            <a:srgbClr val="10B981"/>
+          </a:solidFill>
+          <a:ln>
+            <a:noFill/>
+          </a:ln>
+        </p:spPr>
+        <p:style>
+          <a:lnRef idx="1">
+            <a:schemeClr val="accent1"/>
+          </a:lnRef>
+          <a:fillRef idx="3">
+            <a:schemeClr val="accent1"/>
+          </a:fillRef>
+          <a:effectRef idx="2">
+            <a:schemeClr val="accent1"/>
+          </a:effectRef>
+          <a:fontRef idx="minor">
+            <a:schemeClr val="lt1"/>
+          </a:fontRef>
+        </p:style>
+        <p:txBody>
+          <a:bodyPr rtlCol="0" anchor="ctr"/>
+          <a:lstStyle/>
+          <a:p>
+            <a:pPr algn="ctr"/>
+          </a:p>
+        </p:txBody>
+      </p:sp>
+      <p:sp>
+        <p:nvSpPr>
+          <p:cNvPr id="4" name="TextBox 3"/>
           <p:cNvSpPr txBox="1"/>
           <p:nvPr/>
         </p:nvSpPr>
         <p:spPr>
           <a:xfrm>
-            <a:off x="731520" y="365760"/>
-            <a:ext cx="1828800" cy="365760"/>
+            <a:off x="960120" y="320040"/>
+            <a:ext cx="10424160" cy="320040"/>
           </a:xfrm>
           <a:prstGeom prst="rect">
             <a:avLst/>
@@ -3839,7 +4121,7 @@
           <a:lstStyle/>
           <a:p>
             <a:pPr>
-              <a:defRPr sz="1400" b="1">
+              <a:defRPr sz="1300" b="1">
                 <a:solidFill>
                   <a:srgbClr val="10B981"/>
                 </a:solidFill>
@@ -3847,43 +4129,7 @@
               </a:defRPr>
             </a:pPr>
             <a:r>
-              <a:t>SLIDE 03</a:t>
-            </a:r>
-          </a:p>
-        </p:txBody>
-      </p:sp>
-      <p:sp>
-        <p:nvSpPr>
-          <p:cNvPr id="4" name="TextBox 3"/>
-          <p:cNvSpPr txBox="1"/>
-          <p:nvPr/>
-        </p:nvSpPr>
-        <p:spPr>
-          <a:xfrm>
-            <a:off x="1828800" y="365760"/>
-            <a:ext cx="9601200" cy="365760"/>
-          </a:xfrm>
-          <a:prstGeom prst="rect">
-            <a:avLst/>
-          </a:prstGeom>
-          <a:noFill/>
-        </p:spPr>
-        <p:txBody>
-          <a:bodyPr wrap="none">
-            <a:spAutoFit/>
-          </a:bodyPr>
-          <a:lstStyle/>
-          <a:p>
-            <a:pPr>
-              <a:defRPr sz="1300" b="1">
-                <a:solidFill>
-                  <a:srgbClr val="5A665B"/>
-                </a:solidFill>
-                <a:latin typeface="Malgun Gothic"/>
-              </a:defRPr>
-            </a:pPr>
-            <a:r>
-              <a:t>|  KEY FEATURES</a:t>
+              <a:t>SLIDE 03  |  KEY FEATURES</a:t>
             </a:r>
           </a:p>
         </p:txBody>
@@ -3896,8 +4142,8 @@
         </p:nvSpPr>
         <p:spPr>
           <a:xfrm>
-            <a:off x="731520" y="685800"/>
-            <a:ext cx="10698480" cy="731520"/>
+            <a:off x="960120" y="621792"/>
+            <a:ext cx="10424160" cy="640080"/>
           </a:xfrm>
           <a:prstGeom prst="rect">
             <a:avLst/>
@@ -3911,9 +4157,9 @@
           <a:lstStyle/>
           <a:p>
             <a:pPr>
-              <a:defRPr sz="2500" b="1">
-                <a:solidFill>
-                  <a:srgbClr val="1A2E26"/>
+              <a:defRPr sz="2400" b="1">
+                <a:solidFill>
+                  <a:srgbClr val="141E18"/>
                 </a:solidFill>
                 <a:latin typeface="Malgun Gothic"/>
               </a:defRPr>
@@ -3932,8 +4178,8 @@
         </p:nvSpPr>
         <p:spPr>
           <a:xfrm>
-            <a:off x="731520" y="1645920"/>
-            <a:ext cx="5175504" cy="2148840"/>
+            <a:off x="731520" y="1463040"/>
+            <a:ext cx="5175504" cy="2240280"/>
           </a:xfrm>
           <a:prstGeom prst="roundRect">
             <a:avLst/>
@@ -3943,7 +4189,7 @@
           </a:solidFill>
           <a:ln w="19050">
             <a:solidFill>
-              <a:srgbClr val="E6E1D5"/>
+              <a:srgbClr val="E2E8E0"/>
             </a:solidFill>
           </a:ln>
         </p:spPr>
@@ -3971,14 +4217,129 @@
       </p:sp>
       <p:sp>
         <p:nvSpPr>
-          <p:cNvPr id="7" name="TextBox 6"/>
+          <p:cNvPr id="7" name="Rounded Rectangle 6"/>
+          <p:cNvSpPr/>
+          <p:nvPr/>
+        </p:nvSpPr>
+        <p:spPr>
+          <a:xfrm>
+            <a:off x="1005840" y="1737360"/>
+            <a:ext cx="640080" cy="365760"/>
+          </a:xfrm>
+          <a:prstGeom prst="roundRect">
+            <a:avLst/>
+          </a:prstGeom>
+          <a:solidFill>
+            <a:srgbClr val="1E4030"/>
+          </a:solidFill>
+          <a:ln>
+            <a:noFill/>
+          </a:ln>
+        </p:spPr>
+        <p:style>
+          <a:lnRef idx="1">
+            <a:schemeClr val="accent1"/>
+          </a:lnRef>
+          <a:fillRef idx="3">
+            <a:schemeClr val="accent1"/>
+          </a:fillRef>
+          <a:effectRef idx="2">
+            <a:schemeClr val="accent1"/>
+          </a:effectRef>
+          <a:fontRef idx="minor">
+            <a:schemeClr val="lt1"/>
+          </a:fontRef>
+        </p:style>
+        <p:txBody>
+          <a:bodyPr rtlCol="0" anchor="ctr"/>
+          <a:lstStyle/>
+          <a:p>
+            <a:pPr algn="ctr"/>
+          </a:p>
+        </p:txBody>
+      </p:sp>
+      <p:sp>
+        <p:nvSpPr>
+          <p:cNvPr id="8" name="TextBox 7"/>
           <p:cNvSpPr txBox="1"/>
           <p:nvPr/>
         </p:nvSpPr>
         <p:spPr>
           <a:xfrm>
-            <a:off x="1005840" y="1828800"/>
-            <a:ext cx="4626864" cy="1783080"/>
+            <a:off x="1005840" y="1719072"/>
+            <a:ext cx="640080" cy="365760"/>
+          </a:xfrm>
+          <a:prstGeom prst="rect">
+            <a:avLst/>
+          </a:prstGeom>
+          <a:noFill/>
+        </p:spPr>
+        <p:txBody>
+          <a:bodyPr wrap="none">
+            <a:spAutoFit/>
+          </a:bodyPr>
+          <a:lstStyle/>
+          <a:p>
+            <a:pPr>
+              <a:defRPr sz="1400" b="1">
+                <a:solidFill>
+                  <a:srgbClr val="FFFFFF"/>
+                </a:solidFill>
+                <a:latin typeface="Outfit"/>
+              </a:defRPr>
+            </a:pPr>
+            <a:r>
+              <a:t>01</a:t>
+            </a:r>
+          </a:p>
+        </p:txBody>
+      </p:sp>
+      <p:sp>
+        <p:nvSpPr>
+          <p:cNvPr id="9" name="TextBox 8"/>
+          <p:cNvSpPr txBox="1"/>
+          <p:nvPr/>
+        </p:nvSpPr>
+        <p:spPr>
+          <a:xfrm>
+            <a:off x="1783080" y="1700784"/>
+            <a:ext cx="3986784" cy="457200"/>
+          </a:xfrm>
+          <a:prstGeom prst="rect">
+            <a:avLst/>
+          </a:prstGeom>
+          <a:noFill/>
+        </p:spPr>
+        <p:txBody>
+          <a:bodyPr wrap="none">
+            <a:spAutoFit/>
+          </a:bodyPr>
+          <a:lstStyle/>
+          <a:p>
+            <a:pPr>
+              <a:defRPr sz="1700" b="1">
+                <a:solidFill>
+                  <a:srgbClr val="141E18"/>
+                </a:solidFill>
+                <a:latin typeface="Malgun Gothic"/>
+              </a:defRPr>
+            </a:pPr>
+            <a:r>
+              <a:t>드래그 앤 드롭 사진 매핑</a:t>
+            </a:r>
+          </a:p>
+        </p:txBody>
+      </p:sp>
+      <p:sp>
+        <p:nvSpPr>
+          <p:cNvPr id="10" name="TextBox 9"/>
+          <p:cNvSpPr txBox="1"/>
+          <p:nvPr/>
+        </p:nvSpPr>
+        <p:spPr>
+          <a:xfrm>
+            <a:off x="1005840" y="2240280"/>
+            <a:ext cx="4626864" cy="1371600"/>
           </a:xfrm>
           <a:prstGeom prst="rect">
             <a:avLst/>
@@ -3992,30 +4353,14 @@
           <a:lstStyle/>
           <a:p>
             <a:pPr>
-              <a:defRPr sz="1800" b="1">
-                <a:solidFill>
-                  <a:srgbClr val="10B981"/>
+              <a:defRPr sz="1400">
+                <a:solidFill>
+                  <a:srgbClr val="556258"/>
                 </a:solidFill>
                 <a:latin typeface="Malgun Gothic"/>
               </a:defRPr>
             </a:pPr>
             <a:r>
-              <a:t>01. 드래그 앤 드롭 사진 매핑</a:t>
-            </a:r>
-          </a:p>
-          <a:p>
-            <a:pPr>
-              <a:spcBef>
-                <a:spcPts val="800"/>
-              </a:spcBef>
-              <a:defRPr sz="1400">
-                <a:solidFill>
-                  <a:srgbClr val="5A665B"/>
-                </a:solidFill>
-                <a:latin typeface="Malgun Gothic"/>
-              </a:defRPr>
-            </a:pPr>
-            <a:r>
               <a:t>현장 피해 사진 및 대응 순서 이미지를 손쉽게 업로드하고 드래그/화살표 버튼으로 자막과 1:1 매칭</a:t>
             </a:r>
           </a:p>
@@ -4023,14 +4368,14 @@
       </p:sp>
       <p:sp>
         <p:nvSpPr>
-          <p:cNvPr id="8" name="Rounded Rectangle 7"/>
+          <p:cNvPr id="11" name="Rounded Rectangle 10"/>
           <p:cNvSpPr/>
           <p:nvPr/>
         </p:nvSpPr>
         <p:spPr>
           <a:xfrm>
-            <a:off x="6272784" y="1645920"/>
-            <a:ext cx="5175504" cy="2148840"/>
+            <a:off x="6272784" y="1463040"/>
+            <a:ext cx="5175504" cy="2240280"/>
           </a:xfrm>
           <a:prstGeom prst="roundRect">
             <a:avLst/>
@@ -4040,7 +4385,7 @@
           </a:solidFill>
           <a:ln w="19050">
             <a:solidFill>
-              <a:srgbClr val="E6E1D5"/>
+              <a:srgbClr val="E2E8E0"/>
             </a:solidFill>
           </a:ln>
         </p:spPr>
@@ -4068,14 +4413,129 @@
       </p:sp>
       <p:sp>
         <p:nvSpPr>
-          <p:cNvPr id="9" name="TextBox 8"/>
+          <p:cNvPr id="12" name="Rounded Rectangle 11"/>
+          <p:cNvSpPr/>
+          <p:nvPr/>
+        </p:nvSpPr>
+        <p:spPr>
+          <a:xfrm>
+            <a:off x="6547104" y="1737360"/>
+            <a:ext cx="640080" cy="365760"/>
+          </a:xfrm>
+          <a:prstGeom prst="roundRect">
+            <a:avLst/>
+          </a:prstGeom>
+          <a:solidFill>
+            <a:srgbClr val="1E4030"/>
+          </a:solidFill>
+          <a:ln>
+            <a:noFill/>
+          </a:ln>
+        </p:spPr>
+        <p:style>
+          <a:lnRef idx="1">
+            <a:schemeClr val="accent1"/>
+          </a:lnRef>
+          <a:fillRef idx="3">
+            <a:schemeClr val="accent1"/>
+          </a:fillRef>
+          <a:effectRef idx="2">
+            <a:schemeClr val="accent1"/>
+          </a:effectRef>
+          <a:fontRef idx="minor">
+            <a:schemeClr val="lt1"/>
+          </a:fontRef>
+        </p:style>
+        <p:txBody>
+          <a:bodyPr rtlCol="0" anchor="ctr"/>
+          <a:lstStyle/>
+          <a:p>
+            <a:pPr algn="ctr"/>
+          </a:p>
+        </p:txBody>
+      </p:sp>
+      <p:sp>
+        <p:nvSpPr>
+          <p:cNvPr id="13" name="TextBox 12"/>
           <p:cNvSpPr txBox="1"/>
           <p:nvPr/>
         </p:nvSpPr>
         <p:spPr>
           <a:xfrm>
-            <a:off x="6547104" y="1828800"/>
-            <a:ext cx="4626864" cy="1783080"/>
+            <a:off x="6547104" y="1719072"/>
+            <a:ext cx="640080" cy="365760"/>
+          </a:xfrm>
+          <a:prstGeom prst="rect">
+            <a:avLst/>
+          </a:prstGeom>
+          <a:noFill/>
+        </p:spPr>
+        <p:txBody>
+          <a:bodyPr wrap="none">
+            <a:spAutoFit/>
+          </a:bodyPr>
+          <a:lstStyle/>
+          <a:p>
+            <a:pPr>
+              <a:defRPr sz="1400" b="1">
+                <a:solidFill>
+                  <a:srgbClr val="FFFFFF"/>
+                </a:solidFill>
+                <a:latin typeface="Outfit"/>
+              </a:defRPr>
+            </a:pPr>
+            <a:r>
+              <a:t>02</a:t>
+            </a:r>
+          </a:p>
+        </p:txBody>
+      </p:sp>
+      <p:sp>
+        <p:nvSpPr>
+          <p:cNvPr id="14" name="TextBox 13"/>
+          <p:cNvSpPr txBox="1"/>
+          <p:nvPr/>
+        </p:nvSpPr>
+        <p:spPr>
+          <a:xfrm>
+            <a:off x="7324344" y="1700784"/>
+            <a:ext cx="3986784" cy="457200"/>
+          </a:xfrm>
+          <a:prstGeom prst="rect">
+            <a:avLst/>
+          </a:prstGeom>
+          <a:noFill/>
+        </p:spPr>
+        <p:txBody>
+          <a:bodyPr wrap="none">
+            <a:spAutoFit/>
+          </a:bodyPr>
+          <a:lstStyle/>
+          <a:p>
+            <a:pPr>
+              <a:defRPr sz="1700" b="1">
+                <a:solidFill>
+                  <a:srgbClr val="141E18"/>
+                </a:solidFill>
+                <a:latin typeface="Malgun Gothic"/>
+              </a:defRPr>
+            </a:pPr>
+            <a:r>
+              <a:t>고품질 한국어 AI 음성 (TTS)</a:t>
+            </a:r>
+          </a:p>
+        </p:txBody>
+      </p:sp>
+      <p:sp>
+        <p:nvSpPr>
+          <p:cNvPr id="15" name="TextBox 14"/>
+          <p:cNvSpPr txBox="1"/>
+          <p:nvPr/>
+        </p:nvSpPr>
+        <p:spPr>
+          <a:xfrm>
+            <a:off x="6547104" y="2240280"/>
+            <a:ext cx="4626864" cy="1371600"/>
           </a:xfrm>
           <a:prstGeom prst="rect">
             <a:avLst/>
@@ -4089,30 +4549,14 @@
           <a:lstStyle/>
           <a:p>
             <a:pPr>
-              <a:defRPr sz="1800" b="1">
-                <a:solidFill>
-                  <a:srgbClr val="10B981"/>
+              <a:defRPr sz="1400">
+                <a:solidFill>
+                  <a:srgbClr val="556258"/>
                 </a:solidFill>
                 <a:latin typeface="Malgun Gothic"/>
               </a:defRPr>
             </a:pPr>
             <a:r>
-              <a:t>02. 고품질 한국어 AI 음성 (TTS)</a:t>
-            </a:r>
-          </a:p>
-          <a:p>
-            <a:pPr>
-              <a:spcBef>
-                <a:spcPts val="800"/>
-              </a:spcBef>
-              <a:defRPr sz="1400">
-                <a:solidFill>
-                  <a:srgbClr val="5A665B"/>
-                </a:solidFill>
-                <a:latin typeface="Malgun Gothic"/>
-              </a:defRPr>
-            </a:pPr>
-            <a:r>
               <a:t>OpenAI 시머, 노바, 오닉스 등 최고급 성우 목소리 지원 및 음성 재생 속도(0.5x~2.0x) 세밀 조절</a:t>
             </a:r>
           </a:p>
@@ -4120,14 +4564,14 @@
       </p:sp>
       <p:sp>
         <p:nvSpPr>
-          <p:cNvPr id="10" name="Rounded Rectangle 9"/>
+          <p:cNvPr id="16" name="Rounded Rectangle 15"/>
           <p:cNvSpPr/>
           <p:nvPr/>
         </p:nvSpPr>
         <p:spPr>
           <a:xfrm>
-            <a:off x="731520" y="4069080"/>
-            <a:ext cx="5175504" cy="2148840"/>
+            <a:off x="731520" y="3977639"/>
+            <a:ext cx="5175504" cy="2240280"/>
           </a:xfrm>
           <a:prstGeom prst="roundRect">
             <a:avLst/>
@@ -4137,7 +4581,7 @@
           </a:solidFill>
           <a:ln w="19050">
             <a:solidFill>
-              <a:srgbClr val="E6E1D5"/>
+              <a:srgbClr val="E2E8E0"/>
             </a:solidFill>
           </a:ln>
         </p:spPr>
@@ -4165,14 +4609,129 @@
       </p:sp>
       <p:sp>
         <p:nvSpPr>
-          <p:cNvPr id="11" name="TextBox 10"/>
+          <p:cNvPr id="17" name="Rounded Rectangle 16"/>
+          <p:cNvSpPr/>
+          <p:nvPr/>
+        </p:nvSpPr>
+        <p:spPr>
+          <a:xfrm>
+            <a:off x="1005840" y="4251959"/>
+            <a:ext cx="640080" cy="365760"/>
+          </a:xfrm>
+          <a:prstGeom prst="roundRect">
+            <a:avLst/>
+          </a:prstGeom>
+          <a:solidFill>
+            <a:srgbClr val="1E4030"/>
+          </a:solidFill>
+          <a:ln>
+            <a:noFill/>
+          </a:ln>
+        </p:spPr>
+        <p:style>
+          <a:lnRef idx="1">
+            <a:schemeClr val="accent1"/>
+          </a:lnRef>
+          <a:fillRef idx="3">
+            <a:schemeClr val="accent1"/>
+          </a:fillRef>
+          <a:effectRef idx="2">
+            <a:schemeClr val="accent1"/>
+          </a:effectRef>
+          <a:fontRef idx="minor">
+            <a:schemeClr val="lt1"/>
+          </a:fontRef>
+        </p:style>
+        <p:txBody>
+          <a:bodyPr rtlCol="0" anchor="ctr"/>
+          <a:lstStyle/>
+          <a:p>
+            <a:pPr algn="ctr"/>
+          </a:p>
+        </p:txBody>
+      </p:sp>
+      <p:sp>
+        <p:nvSpPr>
+          <p:cNvPr id="18" name="TextBox 17"/>
           <p:cNvSpPr txBox="1"/>
           <p:nvPr/>
         </p:nvSpPr>
         <p:spPr>
           <a:xfrm>
-            <a:off x="1005840" y="4251960"/>
-            <a:ext cx="4626864" cy="1783080"/>
+            <a:off x="1005840" y="4233671"/>
+            <a:ext cx="640080" cy="365760"/>
+          </a:xfrm>
+          <a:prstGeom prst="rect">
+            <a:avLst/>
+          </a:prstGeom>
+          <a:noFill/>
+        </p:spPr>
+        <p:txBody>
+          <a:bodyPr wrap="none">
+            <a:spAutoFit/>
+          </a:bodyPr>
+          <a:lstStyle/>
+          <a:p>
+            <a:pPr>
+              <a:defRPr sz="1400" b="1">
+                <a:solidFill>
+                  <a:srgbClr val="FFFFFF"/>
+                </a:solidFill>
+                <a:latin typeface="Outfit"/>
+              </a:defRPr>
+            </a:pPr>
+            <a:r>
+              <a:t>03</a:t>
+            </a:r>
+          </a:p>
+        </p:txBody>
+      </p:sp>
+      <p:sp>
+        <p:nvSpPr>
+          <p:cNvPr id="19" name="TextBox 18"/>
+          <p:cNvSpPr txBox="1"/>
+          <p:nvPr/>
+        </p:nvSpPr>
+        <p:spPr>
+          <a:xfrm>
+            <a:off x="1783080" y="4215383"/>
+            <a:ext cx="3986784" cy="457200"/>
+          </a:xfrm>
+          <a:prstGeom prst="rect">
+            <a:avLst/>
+          </a:prstGeom>
+          <a:noFill/>
+        </p:spPr>
+        <p:txBody>
+          <a:bodyPr wrap="none">
+            <a:spAutoFit/>
+          </a:bodyPr>
+          <a:lstStyle/>
+          <a:p>
+            <a:pPr>
+              <a:defRPr sz="1700" b="1">
+                <a:solidFill>
+                  <a:srgbClr val="141E18"/>
+                </a:solidFill>
+                <a:latin typeface="Malgun Gothic"/>
+              </a:defRPr>
+            </a:pPr>
+            <a:r>
+              <a:t>농정 전용 BGM 오디오 믹싱</a:t>
+            </a:r>
+          </a:p>
+        </p:txBody>
+      </p:sp>
+      <p:sp>
+        <p:nvSpPr>
+          <p:cNvPr id="20" name="TextBox 19"/>
+          <p:cNvSpPr txBox="1"/>
+          <p:nvPr/>
+        </p:nvSpPr>
+        <p:spPr>
+          <a:xfrm>
+            <a:off x="1005840" y="4754879"/>
+            <a:ext cx="4626864" cy="1371600"/>
           </a:xfrm>
           <a:prstGeom prst="rect">
             <a:avLst/>
@@ -4186,30 +4745,14 @@
           <a:lstStyle/>
           <a:p>
             <a:pPr>
-              <a:defRPr sz="1800" b="1">
-                <a:solidFill>
-                  <a:srgbClr val="10B981"/>
+              <a:defRPr sz="1400">
+                <a:solidFill>
+                  <a:srgbClr val="556258"/>
                 </a:solidFill>
                 <a:latin typeface="Malgun Gothic"/>
               </a:defRPr>
             </a:pPr>
             <a:r>
-              <a:t>03. 농정 전용 BGM 오디오 믹싱</a:t>
-            </a:r>
-          </a:p>
-          <a:p>
-            <a:pPr>
-              <a:spcBef>
-                <a:spcPts val="800"/>
-              </a:spcBef>
-              <a:defRPr sz="1400">
-                <a:solidFill>
-                  <a:srgbClr val="5A665B"/>
-                </a:solidFill>
-                <a:latin typeface="Malgun Gothic"/>
-              </a:defRPr>
-            </a:pPr>
-            <a:r>
               <a:t>Fields of Opportunity 등 고품질 배경음악 5종 탑재, 실시간 미리듣기 및 음성/BGM 믹싱 볼륨 제어</a:t>
             </a:r>
           </a:p>
@@ -4217,14 +4760,14 @@
       </p:sp>
       <p:sp>
         <p:nvSpPr>
-          <p:cNvPr id="12" name="Rounded Rectangle 11"/>
+          <p:cNvPr id="21" name="Rounded Rectangle 20"/>
           <p:cNvSpPr/>
           <p:nvPr/>
         </p:nvSpPr>
         <p:spPr>
           <a:xfrm>
-            <a:off x="6272784" y="4069080"/>
-            <a:ext cx="5175504" cy="2148840"/>
+            <a:off x="6272784" y="3977639"/>
+            <a:ext cx="5175504" cy="2240280"/>
           </a:xfrm>
           <a:prstGeom prst="roundRect">
             <a:avLst/>
@@ -4234,7 +4777,7 @@
           </a:solidFill>
           <a:ln w="19050">
             <a:solidFill>
-              <a:srgbClr val="E6E1D5"/>
+              <a:srgbClr val="E2E8E0"/>
             </a:solidFill>
           </a:ln>
         </p:spPr>
@@ -4262,14 +4805,129 @@
       </p:sp>
       <p:sp>
         <p:nvSpPr>
-          <p:cNvPr id="13" name="TextBox 12"/>
+          <p:cNvPr id="22" name="Rounded Rectangle 21"/>
+          <p:cNvSpPr/>
+          <p:nvPr/>
+        </p:nvSpPr>
+        <p:spPr>
+          <a:xfrm>
+            <a:off x="6547104" y="4251959"/>
+            <a:ext cx="640080" cy="365760"/>
+          </a:xfrm>
+          <a:prstGeom prst="roundRect">
+            <a:avLst/>
+          </a:prstGeom>
+          <a:solidFill>
+            <a:srgbClr val="1E4030"/>
+          </a:solidFill>
+          <a:ln>
+            <a:noFill/>
+          </a:ln>
+        </p:spPr>
+        <p:style>
+          <a:lnRef idx="1">
+            <a:schemeClr val="accent1"/>
+          </a:lnRef>
+          <a:fillRef idx="3">
+            <a:schemeClr val="accent1"/>
+          </a:fillRef>
+          <a:effectRef idx="2">
+            <a:schemeClr val="accent1"/>
+          </a:effectRef>
+          <a:fontRef idx="minor">
+            <a:schemeClr val="lt1"/>
+          </a:fontRef>
+        </p:style>
+        <p:txBody>
+          <a:bodyPr rtlCol="0" anchor="ctr"/>
+          <a:lstStyle/>
+          <a:p>
+            <a:pPr algn="ctr"/>
+          </a:p>
+        </p:txBody>
+      </p:sp>
+      <p:sp>
+        <p:nvSpPr>
+          <p:cNvPr id="23" name="TextBox 22"/>
           <p:cNvSpPr txBox="1"/>
           <p:nvPr/>
         </p:nvSpPr>
         <p:spPr>
           <a:xfrm>
-            <a:off x="6547104" y="4251960"/>
-            <a:ext cx="4626864" cy="1783080"/>
+            <a:off x="6547104" y="4233671"/>
+            <a:ext cx="640080" cy="365760"/>
+          </a:xfrm>
+          <a:prstGeom prst="rect">
+            <a:avLst/>
+          </a:prstGeom>
+          <a:noFill/>
+        </p:spPr>
+        <p:txBody>
+          <a:bodyPr wrap="none">
+            <a:spAutoFit/>
+          </a:bodyPr>
+          <a:lstStyle/>
+          <a:p>
+            <a:pPr>
+              <a:defRPr sz="1400" b="1">
+                <a:solidFill>
+                  <a:srgbClr val="FFFFFF"/>
+                </a:solidFill>
+                <a:latin typeface="Outfit"/>
+              </a:defRPr>
+            </a:pPr>
+            <a:r>
+              <a:t>04</a:t>
+            </a:r>
+          </a:p>
+        </p:txBody>
+      </p:sp>
+      <p:sp>
+        <p:nvSpPr>
+          <p:cNvPr id="24" name="TextBox 23"/>
+          <p:cNvSpPr txBox="1"/>
+          <p:nvPr/>
+        </p:nvSpPr>
+        <p:spPr>
+          <a:xfrm>
+            <a:off x="7324344" y="4215383"/>
+            <a:ext cx="3986784" cy="457200"/>
+          </a:xfrm>
+          <a:prstGeom prst="rect">
+            <a:avLst/>
+          </a:prstGeom>
+          <a:noFill/>
+        </p:spPr>
+        <p:txBody>
+          <a:bodyPr wrap="none">
+            <a:spAutoFit/>
+          </a:bodyPr>
+          <a:lstStyle/>
+          <a:p>
+            <a:pPr>
+              <a:defRPr sz="1700" b="1">
+                <a:solidFill>
+                  <a:srgbClr val="141E18"/>
+                </a:solidFill>
+                <a:latin typeface="Malgun Gothic"/>
+              </a:defRPr>
+            </a:pPr>
+            <a:r>
+              <a:t>9:16 모바일 MP4 동영상 생성</a:t>
+            </a:r>
+          </a:p>
+        </p:txBody>
+      </p:sp>
+      <p:sp>
+        <p:nvSpPr>
+          <p:cNvPr id="25" name="TextBox 24"/>
+          <p:cNvSpPr txBox="1"/>
+          <p:nvPr/>
+        </p:nvSpPr>
+        <p:spPr>
+          <a:xfrm>
+            <a:off x="6547104" y="4754879"/>
+            <a:ext cx="4626864" cy="1371600"/>
           </a:xfrm>
           <a:prstGeom prst="rect">
             <a:avLst/>
@@ -4283,25 +4941,9 @@
           <a:lstStyle/>
           <a:p>
             <a:pPr>
-              <a:defRPr sz="1800" b="1">
-                <a:solidFill>
-                  <a:srgbClr val="10B981"/>
-                </a:solidFill>
-                <a:latin typeface="Malgun Gothic"/>
-              </a:defRPr>
-            </a:pPr>
-            <a:r>
-              <a:t>04. 9:16 모바일 MP4 동영상 생성</a:t>
-            </a:r>
-          </a:p>
-          <a:p>
-            <a:pPr>
-              <a:spcBef>
-                <a:spcPts val="800"/>
-              </a:spcBef>
               <a:defRPr sz="1400">
                 <a:solidFill>
-                  <a:srgbClr val="5A665B"/>
+                  <a:srgbClr val="556258"/>
                 </a:solidFill>
                 <a:latin typeface="Malgun Gothic"/>
               </a:defRPr>
@@ -4345,7 +4987,7 @@
             <a:avLst/>
           </a:prstGeom>
           <a:solidFill>
-            <a:srgbClr val="F8F6F0"/>
+            <a:srgbClr val="F6F8F5"/>
           </a:solidFill>
           <a:ln>
             <a:noFill/>
@@ -4375,14 +5017,57 @@
       </p:sp>
       <p:sp>
         <p:nvSpPr>
-          <p:cNvPr id="3" name="TextBox 2"/>
+          <p:cNvPr id="3" name="Rounded Rectangle 2"/>
+          <p:cNvSpPr/>
+          <p:nvPr/>
+        </p:nvSpPr>
+        <p:spPr>
+          <a:xfrm>
+            <a:off x="731520" y="365760"/>
+            <a:ext cx="109728" cy="822960"/>
+          </a:xfrm>
+          <a:prstGeom prst="roundRect">
+            <a:avLst/>
+          </a:prstGeom>
+          <a:solidFill>
+            <a:srgbClr val="10B981"/>
+          </a:solidFill>
+          <a:ln>
+            <a:noFill/>
+          </a:ln>
+        </p:spPr>
+        <p:style>
+          <a:lnRef idx="1">
+            <a:schemeClr val="accent1"/>
+          </a:lnRef>
+          <a:fillRef idx="3">
+            <a:schemeClr val="accent1"/>
+          </a:fillRef>
+          <a:effectRef idx="2">
+            <a:schemeClr val="accent1"/>
+          </a:effectRef>
+          <a:fontRef idx="minor">
+            <a:schemeClr val="lt1"/>
+          </a:fontRef>
+        </p:style>
+        <p:txBody>
+          <a:bodyPr rtlCol="0" anchor="ctr"/>
+          <a:lstStyle/>
+          <a:p>
+            <a:pPr algn="ctr"/>
+          </a:p>
+        </p:txBody>
+      </p:sp>
+      <p:sp>
+        <p:nvSpPr>
+          <p:cNvPr id="4" name="TextBox 3"/>
           <p:cNvSpPr txBox="1"/>
           <p:nvPr/>
         </p:nvSpPr>
         <p:spPr>
           <a:xfrm>
-            <a:off x="731520" y="365760"/>
-            <a:ext cx="1828800" cy="365760"/>
+            <a:off x="960120" y="320040"/>
+            <a:ext cx="10424160" cy="320040"/>
           </a:xfrm>
           <a:prstGeom prst="rect">
             <a:avLst/>
@@ -4396,7 +5081,7 @@
           <a:lstStyle/>
           <a:p>
             <a:pPr>
-              <a:defRPr sz="1400" b="1">
+              <a:defRPr sz="1300" b="1">
                 <a:solidFill>
                   <a:srgbClr val="10B981"/>
                 </a:solidFill>
@@ -4404,43 +5089,7 @@
               </a:defRPr>
             </a:pPr>
             <a:r>
-              <a:t>SLIDE 04</a:t>
-            </a:r>
-          </a:p>
-        </p:txBody>
-      </p:sp>
-      <p:sp>
-        <p:nvSpPr>
-          <p:cNvPr id="4" name="TextBox 3"/>
-          <p:cNvSpPr txBox="1"/>
-          <p:nvPr/>
-        </p:nvSpPr>
-        <p:spPr>
-          <a:xfrm>
-            <a:off x="1828800" y="365760"/>
-            <a:ext cx="9601200" cy="365760"/>
-          </a:xfrm>
-          <a:prstGeom prst="rect">
-            <a:avLst/>
-          </a:prstGeom>
-          <a:noFill/>
-        </p:spPr>
-        <p:txBody>
-          <a:bodyPr wrap="none">
-            <a:spAutoFit/>
-          </a:bodyPr>
-          <a:lstStyle/>
-          <a:p>
-            <a:pPr>
-              <a:defRPr sz="1300" b="1">
-                <a:solidFill>
-                  <a:srgbClr val="5A665B"/>
-                </a:solidFill>
-                <a:latin typeface="Malgun Gothic"/>
-              </a:defRPr>
-            </a:pPr>
-            <a:r>
-              <a:t>|  SERVICE WORKFLOW</a:t>
+              <a:t>SLIDE 04  |  SERVICE WORKFLOW</a:t>
             </a:r>
           </a:p>
         </p:txBody>
@@ -4453,8 +5102,8 @@
         </p:nvSpPr>
         <p:spPr>
           <a:xfrm>
-            <a:off x="731520" y="685800"/>
-            <a:ext cx="10698480" cy="731520"/>
+            <a:off x="960120" y="621792"/>
+            <a:ext cx="10424160" cy="640080"/>
           </a:xfrm>
           <a:prstGeom prst="rect">
             <a:avLst/>
@@ -4468,9 +5117,9 @@
           <a:lstStyle/>
           <a:p>
             <a:pPr>
-              <a:defRPr sz="2500" b="1">
-                <a:solidFill>
-                  <a:srgbClr val="1A2E26"/>
+              <a:defRPr sz="2400" b="1">
+                <a:solidFill>
+                  <a:srgbClr val="141E18"/>
                 </a:solidFill>
                 <a:latin typeface="Malgun Gothic"/>
               </a:defRPr>
@@ -4489,8 +5138,8 @@
         </p:nvSpPr>
         <p:spPr>
           <a:xfrm>
-            <a:off x="731520" y="1645920"/>
-            <a:ext cx="2450592" cy="4572000"/>
+            <a:off x="731520" y="1463040"/>
+            <a:ext cx="2450592" cy="4754880"/>
           </a:xfrm>
           <a:prstGeom prst="roundRect">
             <a:avLst/>
@@ -4500,7 +5149,7 @@
           </a:solidFill>
           <a:ln w="19050">
             <a:solidFill>
-              <a:srgbClr val="E6E1D5"/>
+              <a:srgbClr val="E2E8E0"/>
             </a:solidFill>
           </a:ln>
         </p:spPr>
@@ -4528,14 +5177,57 @@
       </p:sp>
       <p:sp>
         <p:nvSpPr>
-          <p:cNvPr id="7" name="TextBox 6"/>
+          <p:cNvPr id="7" name="Rounded Rectangle 6"/>
+          <p:cNvSpPr/>
+          <p:nvPr/>
+        </p:nvSpPr>
+        <p:spPr>
+          <a:xfrm>
+            <a:off x="914400" y="1737360"/>
+            <a:ext cx="2084832" cy="457200"/>
+          </a:xfrm>
+          <a:prstGeom prst="roundRect">
+            <a:avLst/>
+          </a:prstGeom>
+          <a:solidFill>
+            <a:srgbClr val="1E4030"/>
+          </a:solidFill>
+          <a:ln>
+            <a:noFill/>
+          </a:ln>
+        </p:spPr>
+        <p:style>
+          <a:lnRef idx="1">
+            <a:schemeClr val="accent1"/>
+          </a:lnRef>
+          <a:fillRef idx="3">
+            <a:schemeClr val="accent1"/>
+          </a:fillRef>
+          <a:effectRef idx="2">
+            <a:schemeClr val="accent1"/>
+          </a:effectRef>
+          <a:fontRef idx="minor">
+            <a:schemeClr val="lt1"/>
+          </a:fontRef>
+        </p:style>
+        <p:txBody>
+          <a:bodyPr rtlCol="0" anchor="ctr"/>
+          <a:lstStyle/>
+          <a:p>
+            <a:pPr algn="ctr"/>
+          </a:p>
+        </p:txBody>
+      </p:sp>
+      <p:sp>
+        <p:nvSpPr>
+          <p:cNvPr id="8" name="TextBox 7"/>
           <p:cNvSpPr txBox="1"/>
           <p:nvPr/>
         </p:nvSpPr>
         <p:spPr>
           <a:xfrm>
-            <a:off x="914400" y="1920240"/>
-            <a:ext cx="2084832" cy="457200"/>
+            <a:off x="914400" y="1783080"/>
+            <a:ext cx="2084832" cy="365760"/>
           </a:xfrm>
           <a:prstGeom prst="rect">
             <a:avLst/>
@@ -4549,28 +5241,28 @@
           <a:lstStyle/>
           <a:p>
             <a:pPr>
-              <a:defRPr sz="2200" b="1">
-                <a:solidFill>
-                  <a:srgbClr val="10B981"/>
+              <a:defRPr sz="1500" b="1">
+                <a:solidFill>
+                  <a:srgbClr val="A7F3D0"/>
                 </a:solidFill>
                 <a:latin typeface="Outfit"/>
               </a:defRPr>
             </a:pPr>
             <a:r>
-              <a:t>STEP 1</a:t>
-            </a:r>
-          </a:p>
-        </p:txBody>
-      </p:sp>
-      <p:sp>
-        <p:nvSpPr>
-          <p:cNvPr id="8" name="TextBox 7"/>
+              <a:t>STEP 01</a:t>
+            </a:r>
+          </a:p>
+        </p:txBody>
+      </p:sp>
+      <p:sp>
+        <p:nvSpPr>
+          <p:cNvPr id="9" name="TextBox 8"/>
           <p:cNvSpPr txBox="1"/>
           <p:nvPr/>
         </p:nvSpPr>
         <p:spPr>
           <a:xfrm>
-            <a:off x="914400" y="2468880"/>
+            <a:off x="914400" y="2377440"/>
             <a:ext cx="2084832" cy="731520"/>
           </a:xfrm>
           <a:prstGeom prst="rect">
@@ -4587,7 +5279,7 @@
             <a:pPr>
               <a:defRPr sz="1900" b="1">
                 <a:solidFill>
-                  <a:srgbClr val="1A2E26"/>
+                  <a:srgbClr val="141E18"/>
                 </a:solidFill>
                 <a:latin typeface="Malgun Gothic"/>
               </a:defRPr>
@@ -4600,14 +5292,14 @@
       </p:sp>
       <p:sp>
         <p:nvSpPr>
-          <p:cNvPr id="9" name="TextBox 8"/>
+          <p:cNvPr id="10" name="TextBox 9"/>
           <p:cNvSpPr txBox="1"/>
           <p:nvPr/>
         </p:nvSpPr>
         <p:spPr>
           <a:xfrm>
-            <a:off x="914400" y="3291840"/>
-            <a:ext cx="2084832" cy="2651760"/>
+            <a:off x="914400" y="3200400"/>
+            <a:ext cx="2084832" cy="2743200"/>
           </a:xfrm>
           <a:prstGeom prst="rect">
             <a:avLst/>
@@ -4623,7 +5315,7 @@
             <a:pPr>
               <a:defRPr sz="1400">
                 <a:solidFill>
-                  <a:srgbClr val="5A665B"/>
+                  <a:srgbClr val="556258"/>
                 </a:solidFill>
                 <a:latin typeface="Malgun Gothic"/>
               </a:defRPr>
@@ -4636,14 +5328,14 @@
       </p:sp>
       <p:sp>
         <p:nvSpPr>
-          <p:cNvPr id="10" name="Rounded Rectangle 9"/>
+          <p:cNvPr id="11" name="Rounded Rectangle 10"/>
           <p:cNvSpPr/>
           <p:nvPr/>
         </p:nvSpPr>
         <p:spPr>
           <a:xfrm>
-            <a:off x="3483864" y="1645920"/>
-            <a:ext cx="2450592" cy="4572000"/>
+            <a:off x="3483864" y="1463040"/>
+            <a:ext cx="2450592" cy="4754880"/>
           </a:xfrm>
           <a:prstGeom prst="roundRect">
             <a:avLst/>
@@ -4653,7 +5345,7 @@
           </a:solidFill>
           <a:ln w="19050">
             <a:solidFill>
-              <a:srgbClr val="E6E1D5"/>
+              <a:srgbClr val="E2E8E0"/>
             </a:solidFill>
           </a:ln>
         </p:spPr>
@@ -4681,14 +5373,57 @@
       </p:sp>
       <p:sp>
         <p:nvSpPr>
-          <p:cNvPr id="11" name="TextBox 10"/>
+          <p:cNvPr id="12" name="Rounded Rectangle 11"/>
+          <p:cNvSpPr/>
+          <p:nvPr/>
+        </p:nvSpPr>
+        <p:spPr>
+          <a:xfrm>
+            <a:off x="3666744" y="1737360"/>
+            <a:ext cx="2084832" cy="457200"/>
+          </a:xfrm>
+          <a:prstGeom prst="roundRect">
+            <a:avLst/>
+          </a:prstGeom>
+          <a:solidFill>
+            <a:srgbClr val="1E4030"/>
+          </a:solidFill>
+          <a:ln>
+            <a:noFill/>
+          </a:ln>
+        </p:spPr>
+        <p:style>
+          <a:lnRef idx="1">
+            <a:schemeClr val="accent1"/>
+          </a:lnRef>
+          <a:fillRef idx="3">
+            <a:schemeClr val="accent1"/>
+          </a:fillRef>
+          <a:effectRef idx="2">
+            <a:schemeClr val="accent1"/>
+          </a:effectRef>
+          <a:fontRef idx="minor">
+            <a:schemeClr val="lt1"/>
+          </a:fontRef>
+        </p:style>
+        <p:txBody>
+          <a:bodyPr rtlCol="0" anchor="ctr"/>
+          <a:lstStyle/>
+          <a:p>
+            <a:pPr algn="ctr"/>
+          </a:p>
+        </p:txBody>
+      </p:sp>
+      <p:sp>
+        <p:nvSpPr>
+          <p:cNvPr id="13" name="TextBox 12"/>
           <p:cNvSpPr txBox="1"/>
           <p:nvPr/>
         </p:nvSpPr>
         <p:spPr>
           <a:xfrm>
-            <a:off x="3666744" y="1920240"/>
-            <a:ext cx="2084832" cy="457200"/>
+            <a:off x="3666744" y="1783080"/>
+            <a:ext cx="2084832" cy="365760"/>
           </a:xfrm>
           <a:prstGeom prst="rect">
             <a:avLst/>
@@ -4702,28 +5437,28 @@
           <a:lstStyle/>
           <a:p>
             <a:pPr>
-              <a:defRPr sz="2200" b="1">
-                <a:solidFill>
-                  <a:srgbClr val="10B981"/>
+              <a:defRPr sz="1500" b="1">
+                <a:solidFill>
+                  <a:srgbClr val="A7F3D0"/>
                 </a:solidFill>
                 <a:latin typeface="Outfit"/>
               </a:defRPr>
             </a:pPr>
             <a:r>
-              <a:t>STEP 2</a:t>
-            </a:r>
-          </a:p>
-        </p:txBody>
-      </p:sp>
-      <p:sp>
-        <p:nvSpPr>
-          <p:cNvPr id="12" name="TextBox 11"/>
+              <a:t>STEP 02</a:t>
+            </a:r>
+          </a:p>
+        </p:txBody>
+      </p:sp>
+      <p:sp>
+        <p:nvSpPr>
+          <p:cNvPr id="14" name="TextBox 13"/>
           <p:cNvSpPr txBox="1"/>
           <p:nvPr/>
         </p:nvSpPr>
         <p:spPr>
           <a:xfrm>
-            <a:off x="3666744" y="2468880"/>
+            <a:off x="3666744" y="2377440"/>
             <a:ext cx="2084832" cy="731520"/>
           </a:xfrm>
           <a:prstGeom prst="rect">
@@ -4740,7 +5475,7 @@
             <a:pPr>
               <a:defRPr sz="1900" b="1">
                 <a:solidFill>
-                  <a:srgbClr val="1A2E26"/>
+                  <a:srgbClr val="141E18"/>
                 </a:solidFill>
                 <a:latin typeface="Malgun Gothic"/>
               </a:defRPr>
@@ -4753,14 +5488,14 @@
       </p:sp>
       <p:sp>
         <p:nvSpPr>
-          <p:cNvPr id="13" name="TextBox 12"/>
+          <p:cNvPr id="15" name="TextBox 14"/>
           <p:cNvSpPr txBox="1"/>
           <p:nvPr/>
         </p:nvSpPr>
         <p:spPr>
           <a:xfrm>
-            <a:off x="3666744" y="3291840"/>
-            <a:ext cx="2084832" cy="2651760"/>
+            <a:off x="3666744" y="3200400"/>
+            <a:ext cx="2084832" cy="2743200"/>
           </a:xfrm>
           <a:prstGeom prst="rect">
             <a:avLst/>
@@ -4776,7 +5511,7 @@
             <a:pPr>
               <a:defRPr sz="1400">
                 <a:solidFill>
-                  <a:srgbClr val="5A665B"/>
+                  <a:srgbClr val="556258"/>
                 </a:solidFill>
                 <a:latin typeface="Malgun Gothic"/>
               </a:defRPr>
@@ -4789,14 +5524,14 @@
       </p:sp>
       <p:sp>
         <p:nvSpPr>
-          <p:cNvPr id="14" name="Rounded Rectangle 13"/>
+          <p:cNvPr id="16" name="Rounded Rectangle 15"/>
           <p:cNvSpPr/>
           <p:nvPr/>
         </p:nvSpPr>
         <p:spPr>
           <a:xfrm>
-            <a:off x="6236208" y="1645920"/>
-            <a:ext cx="2450592" cy="4572000"/>
+            <a:off x="6236208" y="1463040"/>
+            <a:ext cx="2450592" cy="4754880"/>
           </a:xfrm>
           <a:prstGeom prst="roundRect">
             <a:avLst/>
@@ -4806,7 +5541,7 @@
           </a:solidFill>
           <a:ln w="19050">
             <a:solidFill>
-              <a:srgbClr val="E6E1D5"/>
+              <a:srgbClr val="E2E8E0"/>
             </a:solidFill>
           </a:ln>
         </p:spPr>
@@ -4834,14 +5569,57 @@
       </p:sp>
       <p:sp>
         <p:nvSpPr>
-          <p:cNvPr id="15" name="TextBox 14"/>
+          <p:cNvPr id="17" name="Rounded Rectangle 16"/>
+          <p:cNvSpPr/>
+          <p:nvPr/>
+        </p:nvSpPr>
+        <p:spPr>
+          <a:xfrm>
+            <a:off x="6419088" y="1737360"/>
+            <a:ext cx="2084832" cy="457200"/>
+          </a:xfrm>
+          <a:prstGeom prst="roundRect">
+            <a:avLst/>
+          </a:prstGeom>
+          <a:solidFill>
+            <a:srgbClr val="1E4030"/>
+          </a:solidFill>
+          <a:ln>
+            <a:noFill/>
+          </a:ln>
+        </p:spPr>
+        <p:style>
+          <a:lnRef idx="1">
+            <a:schemeClr val="accent1"/>
+          </a:lnRef>
+          <a:fillRef idx="3">
+            <a:schemeClr val="accent1"/>
+          </a:fillRef>
+          <a:effectRef idx="2">
+            <a:schemeClr val="accent1"/>
+          </a:effectRef>
+          <a:fontRef idx="minor">
+            <a:schemeClr val="lt1"/>
+          </a:fontRef>
+        </p:style>
+        <p:txBody>
+          <a:bodyPr rtlCol="0" anchor="ctr"/>
+          <a:lstStyle/>
+          <a:p>
+            <a:pPr algn="ctr"/>
+          </a:p>
+        </p:txBody>
+      </p:sp>
+      <p:sp>
+        <p:nvSpPr>
+          <p:cNvPr id="18" name="TextBox 17"/>
           <p:cNvSpPr txBox="1"/>
           <p:nvPr/>
         </p:nvSpPr>
         <p:spPr>
           <a:xfrm>
-            <a:off x="6419088" y="1920240"/>
-            <a:ext cx="2084832" cy="457200"/>
+            <a:off x="6419088" y="1783080"/>
+            <a:ext cx="2084832" cy="365760"/>
           </a:xfrm>
           <a:prstGeom prst="rect">
             <a:avLst/>
@@ -4855,28 +5633,28 @@
           <a:lstStyle/>
           <a:p>
             <a:pPr>
-              <a:defRPr sz="2200" b="1">
-                <a:solidFill>
-                  <a:srgbClr val="10B981"/>
+              <a:defRPr sz="1500" b="1">
+                <a:solidFill>
+                  <a:srgbClr val="A7F3D0"/>
                 </a:solidFill>
                 <a:latin typeface="Outfit"/>
               </a:defRPr>
             </a:pPr>
             <a:r>
-              <a:t>STEP 3</a:t>
-            </a:r>
-          </a:p>
-        </p:txBody>
-      </p:sp>
-      <p:sp>
-        <p:nvSpPr>
-          <p:cNvPr id="16" name="TextBox 15"/>
+              <a:t>STEP 03</a:t>
+            </a:r>
+          </a:p>
+        </p:txBody>
+      </p:sp>
+      <p:sp>
+        <p:nvSpPr>
+          <p:cNvPr id="19" name="TextBox 18"/>
           <p:cNvSpPr txBox="1"/>
           <p:nvPr/>
         </p:nvSpPr>
         <p:spPr>
           <a:xfrm>
-            <a:off x="6419088" y="2468880"/>
+            <a:off x="6419088" y="2377440"/>
             <a:ext cx="2084832" cy="731520"/>
           </a:xfrm>
           <a:prstGeom prst="rect">
@@ -4893,7 +5671,7 @@
             <a:pPr>
               <a:defRPr sz="1900" b="1">
                 <a:solidFill>
-                  <a:srgbClr val="1A2E26"/>
+                  <a:srgbClr val="141E18"/>
                 </a:solidFill>
                 <a:latin typeface="Malgun Gothic"/>
               </a:defRPr>
@@ -4906,14 +5684,14 @@
       </p:sp>
       <p:sp>
         <p:nvSpPr>
-          <p:cNvPr id="17" name="TextBox 16"/>
+          <p:cNvPr id="20" name="TextBox 19"/>
           <p:cNvSpPr txBox="1"/>
           <p:nvPr/>
         </p:nvSpPr>
         <p:spPr>
           <a:xfrm>
-            <a:off x="6419088" y="3291840"/>
-            <a:ext cx="2084832" cy="2651760"/>
+            <a:off x="6419088" y="3200400"/>
+            <a:ext cx="2084832" cy="2743200"/>
           </a:xfrm>
           <a:prstGeom prst="rect">
             <a:avLst/>
@@ -4929,7 +5707,7 @@
             <a:pPr>
               <a:defRPr sz="1400">
                 <a:solidFill>
-                  <a:srgbClr val="5A665B"/>
+                  <a:srgbClr val="556258"/>
                 </a:solidFill>
                 <a:latin typeface="Malgun Gothic"/>
               </a:defRPr>
@@ -4942,14 +5720,14 @@
       </p:sp>
       <p:sp>
         <p:nvSpPr>
-          <p:cNvPr id="18" name="Rounded Rectangle 17"/>
+          <p:cNvPr id="21" name="Rounded Rectangle 20"/>
           <p:cNvSpPr/>
           <p:nvPr/>
         </p:nvSpPr>
         <p:spPr>
           <a:xfrm>
-            <a:off x="8988552" y="1645920"/>
-            <a:ext cx="2450592" cy="4572000"/>
+            <a:off x="8988552" y="1463040"/>
+            <a:ext cx="2450592" cy="4754880"/>
           </a:xfrm>
           <a:prstGeom prst="roundRect">
             <a:avLst/>
@@ -4959,7 +5737,7 @@
           </a:solidFill>
           <a:ln w="19050">
             <a:solidFill>
-              <a:srgbClr val="E6E1D5"/>
+              <a:srgbClr val="E2E8E0"/>
             </a:solidFill>
           </a:ln>
         </p:spPr>
@@ -4987,14 +5765,57 @@
       </p:sp>
       <p:sp>
         <p:nvSpPr>
-          <p:cNvPr id="19" name="TextBox 18"/>
+          <p:cNvPr id="22" name="Rounded Rectangle 21"/>
+          <p:cNvSpPr/>
+          <p:nvPr/>
+        </p:nvSpPr>
+        <p:spPr>
+          <a:xfrm>
+            <a:off x="9171432" y="1737360"/>
+            <a:ext cx="2084832" cy="457200"/>
+          </a:xfrm>
+          <a:prstGeom prst="roundRect">
+            <a:avLst/>
+          </a:prstGeom>
+          <a:solidFill>
+            <a:srgbClr val="1E4030"/>
+          </a:solidFill>
+          <a:ln>
+            <a:noFill/>
+          </a:ln>
+        </p:spPr>
+        <p:style>
+          <a:lnRef idx="1">
+            <a:schemeClr val="accent1"/>
+          </a:lnRef>
+          <a:fillRef idx="3">
+            <a:schemeClr val="accent1"/>
+          </a:fillRef>
+          <a:effectRef idx="2">
+            <a:schemeClr val="accent1"/>
+          </a:effectRef>
+          <a:fontRef idx="minor">
+            <a:schemeClr val="lt1"/>
+          </a:fontRef>
+        </p:style>
+        <p:txBody>
+          <a:bodyPr rtlCol="0" anchor="ctr"/>
+          <a:lstStyle/>
+          <a:p>
+            <a:pPr algn="ctr"/>
+          </a:p>
+        </p:txBody>
+      </p:sp>
+      <p:sp>
+        <p:nvSpPr>
+          <p:cNvPr id="23" name="TextBox 22"/>
           <p:cNvSpPr txBox="1"/>
           <p:nvPr/>
         </p:nvSpPr>
         <p:spPr>
           <a:xfrm>
-            <a:off x="9171432" y="1920240"/>
-            <a:ext cx="2084832" cy="457200"/>
+            <a:off x="9171432" y="1783080"/>
+            <a:ext cx="2084832" cy="365760"/>
           </a:xfrm>
           <a:prstGeom prst="rect">
             <a:avLst/>
@@ -5008,28 +5829,28 @@
           <a:lstStyle/>
           <a:p>
             <a:pPr>
-              <a:defRPr sz="2200" b="1">
-                <a:solidFill>
-                  <a:srgbClr val="10B981"/>
+              <a:defRPr sz="1500" b="1">
+                <a:solidFill>
+                  <a:srgbClr val="A7F3D0"/>
                 </a:solidFill>
                 <a:latin typeface="Outfit"/>
               </a:defRPr>
             </a:pPr>
             <a:r>
-              <a:t>STEP 4</a:t>
-            </a:r>
-          </a:p>
-        </p:txBody>
-      </p:sp>
-      <p:sp>
-        <p:nvSpPr>
-          <p:cNvPr id="20" name="TextBox 19"/>
+              <a:t>STEP 04</a:t>
+            </a:r>
+          </a:p>
+        </p:txBody>
+      </p:sp>
+      <p:sp>
+        <p:nvSpPr>
+          <p:cNvPr id="24" name="TextBox 23"/>
           <p:cNvSpPr txBox="1"/>
           <p:nvPr/>
         </p:nvSpPr>
         <p:spPr>
           <a:xfrm>
-            <a:off x="9171432" y="2468880"/>
+            <a:off x="9171432" y="2377440"/>
             <a:ext cx="2084832" cy="731520"/>
           </a:xfrm>
           <a:prstGeom prst="rect">
@@ -5046,7 +5867,7 @@
             <a:pPr>
               <a:defRPr sz="1900" b="1">
                 <a:solidFill>
-                  <a:srgbClr val="1A2E26"/>
+                  <a:srgbClr val="141E18"/>
                 </a:solidFill>
                 <a:latin typeface="Malgun Gothic"/>
               </a:defRPr>
@@ -5059,14 +5880,14 @@
       </p:sp>
       <p:sp>
         <p:nvSpPr>
-          <p:cNvPr id="21" name="TextBox 20"/>
+          <p:cNvPr id="25" name="TextBox 24"/>
           <p:cNvSpPr txBox="1"/>
           <p:nvPr/>
         </p:nvSpPr>
         <p:spPr>
           <a:xfrm>
-            <a:off x="9171432" y="3291840"/>
-            <a:ext cx="2084832" cy="2651760"/>
+            <a:off x="9171432" y="3200400"/>
+            <a:ext cx="2084832" cy="2743200"/>
           </a:xfrm>
           <a:prstGeom prst="rect">
             <a:avLst/>
@@ -5082,7 +5903,7 @@
             <a:pPr>
               <a:defRPr sz="1400">
                 <a:solidFill>
-                  <a:srgbClr val="5A665B"/>
+                  <a:srgbClr val="556258"/>
                 </a:solidFill>
                 <a:latin typeface="Malgun Gothic"/>
               </a:defRPr>
@@ -5126,7 +5947,7 @@
             <a:avLst/>
           </a:prstGeom>
           <a:solidFill>
-            <a:srgbClr val="F8F6F0"/>
+            <a:srgbClr val="F6F8F5"/>
           </a:solidFill>
           <a:ln>
             <a:noFill/>
@@ -5156,14 +5977,57 @@
       </p:sp>
       <p:sp>
         <p:nvSpPr>
-          <p:cNvPr id="3" name="TextBox 2"/>
+          <p:cNvPr id="3" name="Rounded Rectangle 2"/>
+          <p:cNvSpPr/>
+          <p:nvPr/>
+        </p:nvSpPr>
+        <p:spPr>
+          <a:xfrm>
+            <a:off x="731520" y="365760"/>
+            <a:ext cx="109728" cy="822960"/>
+          </a:xfrm>
+          <a:prstGeom prst="roundRect">
+            <a:avLst/>
+          </a:prstGeom>
+          <a:solidFill>
+            <a:srgbClr val="10B981"/>
+          </a:solidFill>
+          <a:ln>
+            <a:noFill/>
+          </a:ln>
+        </p:spPr>
+        <p:style>
+          <a:lnRef idx="1">
+            <a:schemeClr val="accent1"/>
+          </a:lnRef>
+          <a:fillRef idx="3">
+            <a:schemeClr val="accent1"/>
+          </a:fillRef>
+          <a:effectRef idx="2">
+            <a:schemeClr val="accent1"/>
+          </a:effectRef>
+          <a:fontRef idx="minor">
+            <a:schemeClr val="lt1"/>
+          </a:fontRef>
+        </p:style>
+        <p:txBody>
+          <a:bodyPr rtlCol="0" anchor="ctr"/>
+          <a:lstStyle/>
+          <a:p>
+            <a:pPr algn="ctr"/>
+          </a:p>
+        </p:txBody>
+      </p:sp>
+      <p:sp>
+        <p:nvSpPr>
+          <p:cNvPr id="4" name="TextBox 3"/>
           <p:cNvSpPr txBox="1"/>
           <p:nvPr/>
         </p:nvSpPr>
         <p:spPr>
           <a:xfrm>
-            <a:off x="731520" y="365760"/>
-            <a:ext cx="1828800" cy="365760"/>
+            <a:off x="960120" y="320040"/>
+            <a:ext cx="10424160" cy="320040"/>
           </a:xfrm>
           <a:prstGeom prst="rect">
             <a:avLst/>
@@ -5177,7 +6041,7 @@
           <a:lstStyle/>
           <a:p>
             <a:pPr>
-              <a:defRPr sz="1400" b="1">
+              <a:defRPr sz="1300" b="1">
                 <a:solidFill>
                   <a:srgbClr val="10B981"/>
                 </a:solidFill>
@@ -5185,43 +6049,7 @@
               </a:defRPr>
             </a:pPr>
             <a:r>
-              <a:t>SLIDE 05</a:t>
-            </a:r>
-          </a:p>
-        </p:txBody>
-      </p:sp>
-      <p:sp>
-        <p:nvSpPr>
-          <p:cNvPr id="4" name="TextBox 3"/>
-          <p:cNvSpPr txBox="1"/>
-          <p:nvPr/>
-        </p:nvSpPr>
-        <p:spPr>
-          <a:xfrm>
-            <a:off x="1828800" y="365760"/>
-            <a:ext cx="9601200" cy="365760"/>
-          </a:xfrm>
-          <a:prstGeom prst="rect">
-            <a:avLst/>
-          </a:prstGeom>
-          <a:noFill/>
-        </p:spPr>
-        <p:txBody>
-          <a:bodyPr wrap="none">
-            <a:spAutoFit/>
-          </a:bodyPr>
-          <a:lstStyle/>
-          <a:p>
-            <a:pPr>
-              <a:defRPr sz="1300" b="1">
-                <a:solidFill>
-                  <a:srgbClr val="5A665B"/>
-                </a:solidFill>
-                <a:latin typeface="Malgun Gothic"/>
-              </a:defRPr>
-            </a:pPr>
-            <a:r>
-              <a:t>|  TECH ARCHITECTURE</a:t>
+              <a:t>SLIDE 05  |  TECH ARCHITECTURE</a:t>
             </a:r>
           </a:p>
         </p:txBody>
@@ -5234,8 +6062,8 @@
         </p:nvSpPr>
         <p:spPr>
           <a:xfrm>
-            <a:off x="731520" y="685800"/>
-            <a:ext cx="10698480" cy="731520"/>
+            <a:off x="960120" y="621792"/>
+            <a:ext cx="10424160" cy="640080"/>
           </a:xfrm>
           <a:prstGeom prst="rect">
             <a:avLst/>
@@ -5249,9 +6077,9 @@
           <a:lstStyle/>
           <a:p>
             <a:pPr>
-              <a:defRPr sz="2500" b="1">
-                <a:solidFill>
-                  <a:srgbClr val="1A2E26"/>
+              <a:defRPr sz="2400" b="1">
+                <a:solidFill>
+                  <a:srgbClr val="141E18"/>
                 </a:solidFill>
                 <a:latin typeface="Malgun Gothic"/>
               </a:defRPr>
@@ -5270,8 +6098,8 @@
         </p:nvSpPr>
         <p:spPr>
           <a:xfrm>
-            <a:off x="731520" y="1645920"/>
-            <a:ext cx="5212080" cy="4572000"/>
+            <a:off x="731520" y="1463040"/>
+            <a:ext cx="5212080" cy="4754880"/>
           </a:xfrm>
           <a:prstGeom prst="roundRect">
             <a:avLst/>
@@ -5281,7 +6109,7 @@
           </a:solidFill>
           <a:ln w="19050">
             <a:solidFill>
-              <a:srgbClr val="E6E1D5"/>
+              <a:srgbClr val="E2E8E0"/>
             </a:solidFill>
           </a:ln>
         </p:spPr>
@@ -5315,8 +6143,44 @@
         </p:nvSpPr>
         <p:spPr>
           <a:xfrm>
-            <a:off x="1005840" y="1920240"/>
-            <a:ext cx="4663440" cy="4023360"/>
+            <a:off x="1005840" y="1737360"/>
+            <a:ext cx="4663440" cy="457200"/>
+          </a:xfrm>
+          <a:prstGeom prst="rect">
+            <a:avLst/>
+          </a:prstGeom>
+          <a:noFill/>
+        </p:spPr>
+        <p:txBody>
+          <a:bodyPr wrap="none">
+            <a:spAutoFit/>
+          </a:bodyPr>
+          <a:lstStyle/>
+          <a:p>
+            <a:pPr>
+              <a:defRPr sz="1900" b="1">
+                <a:solidFill>
+                  <a:srgbClr val="1E4030"/>
+                </a:solidFill>
+                <a:latin typeface="Malgun Gothic"/>
+              </a:defRPr>
+            </a:pPr>
+            <a:r>
+              <a:t>💻 Frontend &amp; Web Standards</a:t>
+            </a:r>
+          </a:p>
+        </p:txBody>
+      </p:sp>
+      <p:sp>
+        <p:nvSpPr>
+          <p:cNvPr id="8" name="TextBox 7"/>
+          <p:cNvSpPr txBox="1"/>
+          <p:nvPr/>
+        </p:nvSpPr>
+        <p:spPr>
+          <a:xfrm>
+            <a:off x="1005840" y="2286000"/>
+            <a:ext cx="4663440" cy="3749039"/>
           </a:xfrm>
           <a:prstGeom prst="rect">
             <a:avLst/>
@@ -5330,109 +6194,96 @@
           <a:lstStyle/>
           <a:p>
             <a:pPr>
-              <a:defRPr sz="1900" b="1">
-                <a:solidFill>
-                  <a:srgbClr val="4B634E"/>
+              <a:spcAft>
+                <a:spcPts val="1000"/>
+              </a:spcAft>
+              <a:defRPr sz="1400">
+                <a:solidFill>
+                  <a:srgbClr val="141E18"/>
                 </a:solidFill>
                 <a:latin typeface="Malgun Gothic"/>
               </a:defRPr>
             </a:pPr>
             <a:r>
-              <a:t>💻 Frontend &amp; Web Standards</a:t>
+              <a:t>• Vanilla JavaScript: 외부 프레임워크 없는 초고속 반응속도</a:t>
             </a:r>
           </a:p>
           <a:p>
             <a:pPr>
-              <a:spcBef>
+              <a:spcAft>
                 <a:spcPts val="1000"/>
-              </a:spcBef>
+              </a:spcAft>
               <a:defRPr sz="1400">
                 <a:solidFill>
-                  <a:srgbClr val="1E261F"/>
+                  <a:srgbClr val="141E18"/>
                 </a:solidFill>
                 <a:latin typeface="Malgun Gothic"/>
               </a:defRPr>
             </a:pPr>
             <a:r>
-              <a:t>• Vanilla JavaScript: 라이브러리 의존 없는 초고속 로딩</a:t>
+              <a:t>• Canvas 2D API: 9:16 모바일 비디오 실시간 그래픽 렌더링</a:t>
             </a:r>
           </a:p>
           <a:p>
             <a:pPr>
-              <a:spcBef>
+              <a:spcAft>
                 <a:spcPts val="1000"/>
-              </a:spcBef>
+              </a:spcAft>
               <a:defRPr sz="1400">
                 <a:solidFill>
-                  <a:srgbClr val="1E261F"/>
+                  <a:srgbClr val="141E18"/>
                 </a:solidFill>
                 <a:latin typeface="Malgun Gothic"/>
               </a:defRPr>
             </a:pPr>
             <a:r>
-              <a:t>• Canvas 2D API: 9:16 모바일 전용 비디오 렌더링</a:t>
+              <a:t>• Web Audio API: 음성+BGM 실시간 오디오 스트리밍 &amp; 믹싱</a:t>
             </a:r>
           </a:p>
           <a:p>
             <a:pPr>
-              <a:spcBef>
+              <a:spcAft>
                 <a:spcPts val="1000"/>
-              </a:spcBef>
+              </a:spcAft>
               <a:defRPr sz="1400">
                 <a:solidFill>
-                  <a:srgbClr val="1E261F"/>
+                  <a:srgbClr val="141E18"/>
                 </a:solidFill>
                 <a:latin typeface="Malgun Gothic"/>
               </a:defRPr>
             </a:pPr>
             <a:r>
-              <a:t>• Web Audio API: 음성+BGM 실시간 스트리밍 &amp; 오디오 믹싱</a:t>
+              <a:t>• MediaRecorder API: 웹 브라우저 단독 MP4 비디오 인코딩</a:t>
             </a:r>
           </a:p>
           <a:p>
             <a:pPr>
-              <a:spcBef>
+              <a:spcAft>
                 <a:spcPts val="1000"/>
-              </a:spcBef>
+              </a:spcAft>
               <a:defRPr sz="1400">
                 <a:solidFill>
-                  <a:srgbClr val="1E261F"/>
+                  <a:srgbClr val="141E18"/>
                 </a:solidFill>
                 <a:latin typeface="Malgun Gothic"/>
               </a:defRPr>
             </a:pPr>
             <a:r>
-              <a:t>• MediaRecorder API: 웹 브라우저 내 MP4 동영상 인코딩</a:t>
-            </a:r>
-          </a:p>
-          <a:p>
-            <a:pPr>
-              <a:spcBef>
-                <a:spcPts val="1000"/>
-              </a:spcBef>
-              <a:defRPr sz="1400">
-                <a:solidFill>
-                  <a:srgbClr val="1E261F"/>
-                </a:solidFill>
-                <a:latin typeface="Malgun Gothic"/>
-              </a:defRPr>
-            </a:pPr>
-            <a:r>
-              <a:t>• GOBE Luxury Design: 라이트 모드 고정 및 모바일 반응형 UX</a:t>
-            </a:r>
-          </a:p>
-        </p:txBody>
-      </p:sp>
-      <p:sp>
-        <p:nvSpPr>
-          <p:cNvPr id="8" name="Rounded Rectangle 7"/>
+              <a:t>• GOBE Luxury System: 다크모드 반전 방지 라이트모드 UI</a:t>
+            </a:r>
+          </a:p>
+        </p:txBody>
+      </p:sp>
+      <p:sp>
+        <p:nvSpPr>
+          <p:cNvPr id="9" name="Rounded Rectangle 8"/>
           <p:cNvSpPr/>
           <p:nvPr/>
         </p:nvSpPr>
         <p:spPr>
           <a:xfrm>
-            <a:off x="6248095" y="1645920"/>
-            <a:ext cx="5212080" cy="4572000"/>
+            <a:off x="6248095" y="1463040"/>
+            <a:ext cx="5212080" cy="4754880"/>
           </a:xfrm>
           <a:prstGeom prst="roundRect">
             <a:avLst/>
@@ -5442,7 +6293,7 @@
           </a:solidFill>
           <a:ln w="19050">
             <a:solidFill>
-              <a:srgbClr val="E6E1D5"/>
+              <a:srgbClr val="E2E8E0"/>
             </a:solidFill>
           </a:ln>
         </p:spPr>
@@ -5470,14 +6321,50 @@
       </p:sp>
       <p:sp>
         <p:nvSpPr>
-          <p:cNvPr id="9" name="TextBox 8"/>
+          <p:cNvPr id="10" name="TextBox 9"/>
           <p:cNvSpPr txBox="1"/>
           <p:nvPr/>
         </p:nvSpPr>
         <p:spPr>
           <a:xfrm>
-            <a:off x="6522415" y="1920240"/>
-            <a:ext cx="4663440" cy="4023360"/>
+            <a:off x="6522415" y="1737360"/>
+            <a:ext cx="4663440" cy="457200"/>
+          </a:xfrm>
+          <a:prstGeom prst="rect">
+            <a:avLst/>
+          </a:prstGeom>
+          <a:noFill/>
+        </p:spPr>
+        <p:txBody>
+          <a:bodyPr wrap="none">
+            <a:spAutoFit/>
+          </a:bodyPr>
+          <a:lstStyle/>
+          <a:p>
+            <a:pPr>
+              <a:defRPr sz="1900" b="1">
+                <a:solidFill>
+                  <a:srgbClr val="1E4030"/>
+                </a:solidFill>
+                <a:latin typeface="Malgun Gothic"/>
+              </a:defRPr>
+            </a:pPr>
+            <a:r>
+              <a:t>⚙️ Backend &amp; Cloud Infrastructure</a:t>
+            </a:r>
+          </a:p>
+        </p:txBody>
+      </p:sp>
+      <p:sp>
+        <p:nvSpPr>
+          <p:cNvPr id="11" name="TextBox 10"/>
+          <p:cNvSpPr txBox="1"/>
+          <p:nvPr/>
+        </p:nvSpPr>
+        <p:spPr>
+          <a:xfrm>
+            <a:off x="6522415" y="2286000"/>
+            <a:ext cx="4663440" cy="3749039"/>
           </a:xfrm>
           <a:prstGeom prst="rect">
             <a:avLst/>
@@ -5491,95 +6378,82 @@
           <a:lstStyle/>
           <a:p>
             <a:pPr>
-              <a:defRPr sz="1900" b="1">
-                <a:solidFill>
-                  <a:srgbClr val="4B634E"/>
+              <a:spcAft>
+                <a:spcPts val="1000"/>
+              </a:spcAft>
+              <a:defRPr sz="1400">
+                <a:solidFill>
+                  <a:srgbClr val="141E18"/>
                 </a:solidFill>
                 <a:latin typeface="Malgun Gothic"/>
               </a:defRPr>
             </a:pPr>
             <a:r>
-              <a:t>⚙️ Backend &amp; Cloud Infrastructure</a:t>
+              <a:t>• Python HTTP API Server: 경량 RESTful backend 서버 구축</a:t>
             </a:r>
           </a:p>
           <a:p>
             <a:pPr>
-              <a:spcBef>
+              <a:spcAft>
                 <a:spcPts val="1000"/>
-              </a:spcBef>
+              </a:spcAft>
               <a:defRPr sz="1400">
                 <a:solidFill>
-                  <a:srgbClr val="1E261F"/>
+                  <a:srgbClr val="141E18"/>
                 </a:solidFill>
                 <a:latin typeface="Malgun Gothic"/>
               </a:defRPr>
             </a:pPr>
             <a:r>
-              <a:t>• Python HTTP API Server: 경량 RESTful API 서버 구축</a:t>
+              <a:t>• OpenAI Speech REST API: 시머, 오닉스 등 고품질 TTS 연동</a:t>
             </a:r>
           </a:p>
           <a:p>
             <a:pPr>
-              <a:spcBef>
+              <a:spcAft>
                 <a:spcPts val="1000"/>
-              </a:spcBef>
+              </a:spcAft>
               <a:defRPr sz="1400">
                 <a:solidFill>
-                  <a:srgbClr val="1E261F"/>
+                  <a:srgbClr val="141E18"/>
                 </a:solidFill>
                 <a:latin typeface="Malgun Gothic"/>
               </a:defRPr>
             </a:pPr>
             <a:r>
-              <a:t>• OpenAI Speech REST API: 시머, 오닉스 등 유료 TTS 연동</a:t>
+              <a:t>• API Key Security: Base64 인코딩 및 환경변수 자동 매핑</a:t>
             </a:r>
           </a:p>
           <a:p>
             <a:pPr>
-              <a:spcBef>
+              <a:spcAft>
                 <a:spcPts val="1000"/>
-              </a:spcBef>
+              </a:spcAft>
               <a:defRPr sz="1400">
                 <a:solidFill>
-                  <a:srgbClr val="1E261F"/>
+                  <a:srgbClr val="141E18"/>
                 </a:solidFill>
                 <a:latin typeface="Malgun Gothic"/>
               </a:defRPr>
             </a:pPr>
             <a:r>
-              <a:t>• API Key Security: Base64 인코딩 및 환경변수 안전 관리</a:t>
+              <a:t>• 24/7 Cloud Service: Render Cloud 배포로 모바일 언제나 접속</a:t>
             </a:r>
           </a:p>
           <a:p>
             <a:pPr>
-              <a:spcBef>
+              <a:spcAft>
                 <a:spcPts val="1000"/>
-              </a:spcBef>
+              </a:spcAft>
               <a:defRPr sz="1400">
                 <a:solidFill>
-                  <a:srgbClr val="1E261F"/>
+                  <a:srgbClr val="141E18"/>
                 </a:solidFill>
                 <a:latin typeface="Malgun Gothic"/>
               </a:defRPr>
             </a:pPr>
             <a:r>
-              <a:t>• 24/7 Cloud Deployment: Render Cloud 클라우드 배포</a:t>
-            </a:r>
-          </a:p>
-          <a:p>
-            <a:pPr>
-              <a:spcBef>
-                <a:spcPts val="1000"/>
-              </a:spcBef>
-              <a:defRPr sz="1400">
-                <a:solidFill>
-                  <a:srgbClr val="1E261F"/>
-                </a:solidFill>
-                <a:latin typeface="Malgun Gothic"/>
-              </a:defRPr>
-            </a:pPr>
-            <a:r>
-              <a:t>• QR Code Connection: QR코드 스캔만으로 모바일 즉시 접근</a:t>
+              <a:t>• QR Code Quick Connect: QR스캔만으로 스마트폰 즉시 실행</a:t>
             </a:r>
           </a:p>
         </p:txBody>
@@ -5617,7 +6491,7 @@
             <a:avLst/>
           </a:prstGeom>
           <a:solidFill>
-            <a:srgbClr val="F8F6F0"/>
+            <a:srgbClr val="F6F8F5"/>
           </a:solidFill>
           <a:ln>
             <a:noFill/>
@@ -5647,14 +6521,57 @@
       </p:sp>
       <p:sp>
         <p:nvSpPr>
-          <p:cNvPr id="3" name="TextBox 2"/>
+          <p:cNvPr id="3" name="Rounded Rectangle 2"/>
+          <p:cNvSpPr/>
+          <p:nvPr/>
+        </p:nvSpPr>
+        <p:spPr>
+          <a:xfrm>
+            <a:off x="731520" y="365760"/>
+            <a:ext cx="109728" cy="822960"/>
+          </a:xfrm>
+          <a:prstGeom prst="roundRect">
+            <a:avLst/>
+          </a:prstGeom>
+          <a:solidFill>
+            <a:srgbClr val="10B981"/>
+          </a:solidFill>
+          <a:ln>
+            <a:noFill/>
+          </a:ln>
+        </p:spPr>
+        <p:style>
+          <a:lnRef idx="1">
+            <a:schemeClr val="accent1"/>
+          </a:lnRef>
+          <a:fillRef idx="3">
+            <a:schemeClr val="accent1"/>
+          </a:fillRef>
+          <a:effectRef idx="2">
+            <a:schemeClr val="accent1"/>
+          </a:effectRef>
+          <a:fontRef idx="minor">
+            <a:schemeClr val="lt1"/>
+          </a:fontRef>
+        </p:style>
+        <p:txBody>
+          <a:bodyPr rtlCol="0" anchor="ctr"/>
+          <a:lstStyle/>
+          <a:p>
+            <a:pPr algn="ctr"/>
+          </a:p>
+        </p:txBody>
+      </p:sp>
+      <p:sp>
+        <p:nvSpPr>
+          <p:cNvPr id="4" name="TextBox 3"/>
           <p:cNvSpPr txBox="1"/>
           <p:nvPr/>
         </p:nvSpPr>
         <p:spPr>
           <a:xfrm>
-            <a:off x="731520" y="365760"/>
-            <a:ext cx="1828800" cy="365760"/>
+            <a:off x="960120" y="320040"/>
+            <a:ext cx="10424160" cy="320040"/>
           </a:xfrm>
           <a:prstGeom prst="rect">
             <a:avLst/>
@@ -5668,7 +6585,7 @@
           <a:lstStyle/>
           <a:p>
             <a:pPr>
-              <a:defRPr sz="1400" b="1">
+              <a:defRPr sz="1300" b="1">
                 <a:solidFill>
                   <a:srgbClr val="10B981"/>
                 </a:solidFill>
@@ -5676,43 +6593,7 @@
               </a:defRPr>
             </a:pPr>
             <a:r>
-              <a:t>SLIDE 06</a:t>
-            </a:r>
-          </a:p>
-        </p:txBody>
-      </p:sp>
-      <p:sp>
-        <p:nvSpPr>
-          <p:cNvPr id="4" name="TextBox 3"/>
-          <p:cNvSpPr txBox="1"/>
-          <p:nvPr/>
-        </p:nvSpPr>
-        <p:spPr>
-          <a:xfrm>
-            <a:off x="1828800" y="365760"/>
-            <a:ext cx="9601200" cy="365760"/>
-          </a:xfrm>
-          <a:prstGeom prst="rect">
-            <a:avLst/>
-          </a:prstGeom>
-          <a:noFill/>
-        </p:spPr>
-        <p:txBody>
-          <a:bodyPr wrap="none">
-            <a:spAutoFit/>
-          </a:bodyPr>
-          <a:lstStyle/>
-          <a:p>
-            <a:pPr>
-              <a:defRPr sz="1300" b="1">
-                <a:solidFill>
-                  <a:srgbClr val="5A665B"/>
-                </a:solidFill>
-                <a:latin typeface="Malgun Gothic"/>
-              </a:defRPr>
-            </a:pPr>
-            <a:r>
-              <a:t>|  EXPECTED IMPACT</a:t>
+              <a:t>SLIDE 06  |  EXPECTED IMPACT</a:t>
             </a:r>
           </a:p>
         </p:txBody>
@@ -5725,8 +6606,8 @@
         </p:nvSpPr>
         <p:spPr>
           <a:xfrm>
-            <a:off x="731520" y="685800"/>
-            <a:ext cx="10698480" cy="731520"/>
+            <a:off x="960120" y="621792"/>
+            <a:ext cx="10424160" cy="640080"/>
           </a:xfrm>
           <a:prstGeom prst="rect">
             <a:avLst/>
@@ -5740,9 +6621,9 @@
           <a:lstStyle/>
           <a:p>
             <a:pPr>
-              <a:defRPr sz="2500" b="1">
-                <a:solidFill>
-                  <a:srgbClr val="1A2E26"/>
+              <a:defRPr sz="2400" b="1">
+                <a:solidFill>
+                  <a:srgbClr val="141E18"/>
                 </a:solidFill>
                 <a:latin typeface="Malgun Gothic"/>
               </a:defRPr>
@@ -5761,8 +6642,8 @@
         </p:nvSpPr>
         <p:spPr>
           <a:xfrm>
-            <a:off x="731520" y="1645920"/>
-            <a:ext cx="3328416" cy="4572000"/>
+            <a:off x="731520" y="1463040"/>
+            <a:ext cx="3328416" cy="4754880"/>
           </a:xfrm>
           <a:prstGeom prst="roundRect">
             <a:avLst/>
@@ -5772,7 +6653,7 @@
           </a:solidFill>
           <a:ln w="19050">
             <a:solidFill>
-              <a:srgbClr val="E6E1D5"/>
+              <a:srgbClr val="E2E8E0"/>
             </a:solidFill>
           </a:ln>
         </p:spPr>
@@ -5800,13 +6681,58 @@
       </p:sp>
       <p:sp>
         <p:nvSpPr>
-          <p:cNvPr id="7" name="TextBox 6"/>
+          <p:cNvPr id="7" name="Rounded Rectangle 6"/>
+          <p:cNvSpPr/>
+          <p:nvPr/>
+        </p:nvSpPr>
+        <p:spPr>
+          <a:xfrm>
+            <a:off x="1005840" y="1737360"/>
+            <a:ext cx="2779776" cy="822960"/>
+          </a:xfrm>
+          <a:prstGeom prst="roundRect">
+            <a:avLst/>
+          </a:prstGeom>
+          <a:solidFill>
+            <a:srgbClr val="ECFDF5"/>
+          </a:solidFill>
+          <a:ln>
+            <a:solidFill>
+              <a:srgbClr val="10B981"/>
+            </a:solidFill>
+          </a:ln>
+        </p:spPr>
+        <p:style>
+          <a:lnRef idx="1">
+            <a:schemeClr val="accent1"/>
+          </a:lnRef>
+          <a:fillRef idx="3">
+            <a:schemeClr val="accent1"/>
+          </a:fillRef>
+          <a:effectRef idx="2">
+            <a:schemeClr val="accent1"/>
+          </a:effectRef>
+          <a:fontRef idx="minor">
+            <a:schemeClr val="lt1"/>
+          </a:fontRef>
+        </p:style>
+        <p:txBody>
+          <a:bodyPr rtlCol="0" anchor="ctr"/>
+          <a:lstStyle/>
+          <a:p>
+            <a:pPr algn="ctr"/>
+          </a:p>
+        </p:txBody>
+      </p:sp>
+      <p:sp>
+        <p:nvSpPr>
+          <p:cNvPr id="8" name="TextBox 7"/>
           <p:cNvSpPr txBox="1"/>
           <p:nvPr/>
         </p:nvSpPr>
         <p:spPr>
           <a:xfrm>
-            <a:off x="1005840" y="1920240"/>
+            <a:off x="1005840" y="1783080"/>
             <a:ext cx="2779776" cy="731520"/>
           </a:xfrm>
           <a:prstGeom prst="rect">
@@ -5821,7 +6747,7 @@
           <a:lstStyle/>
           <a:p>
             <a:pPr>
-              <a:defRPr sz="3200" b="1">
+              <a:defRPr sz="3000" b="1">
                 <a:solidFill>
                   <a:srgbClr val="10B981"/>
                 </a:solidFill>
@@ -5836,7 +6762,7 @@
       </p:sp>
       <p:sp>
         <p:nvSpPr>
-          <p:cNvPr id="8" name="TextBox 7"/>
+          <p:cNvPr id="9" name="TextBox 8"/>
           <p:cNvSpPr txBox="1"/>
           <p:nvPr/>
         </p:nvSpPr>
@@ -5859,7 +6785,7 @@
             <a:pPr>
               <a:defRPr sz="1900" b="1">
                 <a:solidFill>
-                  <a:srgbClr val="1A2E26"/>
+                  <a:srgbClr val="141E18"/>
                 </a:solidFill>
                 <a:latin typeface="Malgun Gothic"/>
               </a:defRPr>
@@ -5872,7 +6798,7 @@
       </p:sp>
       <p:sp>
         <p:nvSpPr>
-          <p:cNvPr id="9" name="TextBox 8"/>
+          <p:cNvPr id="10" name="TextBox 9"/>
           <p:cNvSpPr txBox="1"/>
           <p:nvPr/>
         </p:nvSpPr>
@@ -5895,7 +6821,7 @@
             <a:pPr>
               <a:defRPr sz="1400">
                 <a:solidFill>
-                  <a:srgbClr val="5A665B"/>
+                  <a:srgbClr val="556258"/>
                 </a:solidFill>
                 <a:latin typeface="Malgun Gothic"/>
               </a:defRPr>
@@ -5908,14 +6834,14 @@
       </p:sp>
       <p:sp>
         <p:nvSpPr>
-          <p:cNvPr id="10" name="Rounded Rectangle 9"/>
+          <p:cNvPr id="11" name="Rounded Rectangle 10"/>
           <p:cNvSpPr/>
           <p:nvPr/>
         </p:nvSpPr>
         <p:spPr>
           <a:xfrm>
-            <a:off x="4425696" y="1645920"/>
-            <a:ext cx="3328416" cy="4572000"/>
+            <a:off x="4425696" y="1463040"/>
+            <a:ext cx="3328416" cy="4754880"/>
           </a:xfrm>
           <a:prstGeom prst="roundRect">
             <a:avLst/>
@@ -5925,7 +6851,7 @@
           </a:solidFill>
           <a:ln w="19050">
             <a:solidFill>
-              <a:srgbClr val="E6E1D5"/>
+              <a:srgbClr val="E2E8E0"/>
             </a:solidFill>
           </a:ln>
         </p:spPr>
@@ -5953,13 +6879,58 @@
       </p:sp>
       <p:sp>
         <p:nvSpPr>
-          <p:cNvPr id="11" name="TextBox 10"/>
+          <p:cNvPr id="12" name="Rounded Rectangle 11"/>
+          <p:cNvSpPr/>
+          <p:nvPr/>
+        </p:nvSpPr>
+        <p:spPr>
+          <a:xfrm>
+            <a:off x="4700016" y="1737360"/>
+            <a:ext cx="2779776" cy="822960"/>
+          </a:xfrm>
+          <a:prstGeom prst="roundRect">
+            <a:avLst/>
+          </a:prstGeom>
+          <a:solidFill>
+            <a:srgbClr val="ECFDF5"/>
+          </a:solidFill>
+          <a:ln>
+            <a:solidFill>
+              <a:srgbClr val="10B981"/>
+            </a:solidFill>
+          </a:ln>
+        </p:spPr>
+        <p:style>
+          <a:lnRef idx="1">
+            <a:schemeClr val="accent1"/>
+          </a:lnRef>
+          <a:fillRef idx="3">
+            <a:schemeClr val="accent1"/>
+          </a:fillRef>
+          <a:effectRef idx="2">
+            <a:schemeClr val="accent1"/>
+          </a:effectRef>
+          <a:fontRef idx="minor">
+            <a:schemeClr val="lt1"/>
+          </a:fontRef>
+        </p:style>
+        <p:txBody>
+          <a:bodyPr rtlCol="0" anchor="ctr"/>
+          <a:lstStyle/>
+          <a:p>
+            <a:pPr algn="ctr"/>
+          </a:p>
+        </p:txBody>
+      </p:sp>
+      <p:sp>
+        <p:nvSpPr>
+          <p:cNvPr id="13" name="TextBox 12"/>
           <p:cNvSpPr txBox="1"/>
           <p:nvPr/>
         </p:nvSpPr>
         <p:spPr>
           <a:xfrm>
-            <a:off x="4700016" y="1920240"/>
+            <a:off x="4700016" y="1783080"/>
             <a:ext cx="2779776" cy="731520"/>
           </a:xfrm>
           <a:prstGeom prst="rect">
@@ -5974,7 +6945,7 @@
           <a:lstStyle/>
           <a:p>
             <a:pPr>
-              <a:defRPr sz="3200" b="1">
+              <a:defRPr sz="3000" b="1">
                 <a:solidFill>
                   <a:srgbClr val="10B981"/>
                 </a:solidFill>
@@ -5989,7 +6960,7 @@
       </p:sp>
       <p:sp>
         <p:nvSpPr>
-          <p:cNvPr id="12" name="TextBox 11"/>
+          <p:cNvPr id="14" name="TextBox 13"/>
           <p:cNvSpPr txBox="1"/>
           <p:nvPr/>
         </p:nvSpPr>
@@ -6012,7 +6983,7 @@
             <a:pPr>
               <a:defRPr sz="1900" b="1">
                 <a:solidFill>
-                  <a:srgbClr val="1A2E26"/>
+                  <a:srgbClr val="141E18"/>
                 </a:solidFill>
                 <a:latin typeface="Malgun Gothic"/>
               </a:defRPr>
@@ -6025,7 +6996,7 @@
       </p:sp>
       <p:sp>
         <p:nvSpPr>
-          <p:cNvPr id="13" name="TextBox 12"/>
+          <p:cNvPr id="15" name="TextBox 14"/>
           <p:cNvSpPr txBox="1"/>
           <p:nvPr/>
         </p:nvSpPr>
@@ -6048,7 +7019,7 @@
             <a:pPr>
               <a:defRPr sz="1400">
                 <a:solidFill>
-                  <a:srgbClr val="5A665B"/>
+                  <a:srgbClr val="556258"/>
                 </a:solidFill>
                 <a:latin typeface="Malgun Gothic"/>
               </a:defRPr>
@@ -6061,14 +7032,14 @@
       </p:sp>
       <p:sp>
         <p:nvSpPr>
-          <p:cNvPr id="14" name="Rounded Rectangle 13"/>
+          <p:cNvPr id="16" name="Rounded Rectangle 15"/>
           <p:cNvSpPr/>
           <p:nvPr/>
         </p:nvSpPr>
         <p:spPr>
           <a:xfrm>
-            <a:off x="8119872" y="1645920"/>
-            <a:ext cx="3328416" cy="4572000"/>
+            <a:off x="8119872" y="1463040"/>
+            <a:ext cx="3328416" cy="4754880"/>
           </a:xfrm>
           <a:prstGeom prst="roundRect">
             <a:avLst/>
@@ -6078,7 +7049,7 @@
           </a:solidFill>
           <a:ln w="19050">
             <a:solidFill>
-              <a:srgbClr val="E6E1D5"/>
+              <a:srgbClr val="E2E8E0"/>
             </a:solidFill>
           </a:ln>
         </p:spPr>
@@ -6106,13 +7077,58 @@
       </p:sp>
       <p:sp>
         <p:nvSpPr>
-          <p:cNvPr id="15" name="TextBox 14"/>
+          <p:cNvPr id="17" name="Rounded Rectangle 16"/>
+          <p:cNvSpPr/>
+          <p:nvPr/>
+        </p:nvSpPr>
+        <p:spPr>
+          <a:xfrm>
+            <a:off x="8394192" y="1737360"/>
+            <a:ext cx="2779776" cy="822960"/>
+          </a:xfrm>
+          <a:prstGeom prst="roundRect">
+            <a:avLst/>
+          </a:prstGeom>
+          <a:solidFill>
+            <a:srgbClr val="ECFDF5"/>
+          </a:solidFill>
+          <a:ln>
+            <a:solidFill>
+              <a:srgbClr val="10B981"/>
+            </a:solidFill>
+          </a:ln>
+        </p:spPr>
+        <p:style>
+          <a:lnRef idx="1">
+            <a:schemeClr val="accent1"/>
+          </a:lnRef>
+          <a:fillRef idx="3">
+            <a:schemeClr val="accent1"/>
+          </a:fillRef>
+          <a:effectRef idx="2">
+            <a:schemeClr val="accent1"/>
+          </a:effectRef>
+          <a:fontRef idx="minor">
+            <a:schemeClr val="lt1"/>
+          </a:fontRef>
+        </p:style>
+        <p:txBody>
+          <a:bodyPr rtlCol="0" anchor="ctr"/>
+          <a:lstStyle/>
+          <a:p>
+            <a:pPr algn="ctr"/>
+          </a:p>
+        </p:txBody>
+      </p:sp>
+      <p:sp>
+        <p:nvSpPr>
+          <p:cNvPr id="18" name="TextBox 17"/>
           <p:cNvSpPr txBox="1"/>
           <p:nvPr/>
         </p:nvSpPr>
         <p:spPr>
           <a:xfrm>
-            <a:off x="8394192" y="1920240"/>
+            <a:off x="8394192" y="1783080"/>
             <a:ext cx="2779776" cy="731520"/>
           </a:xfrm>
           <a:prstGeom prst="rect">
@@ -6127,7 +7143,7 @@
           <a:lstStyle/>
           <a:p>
             <a:pPr>
-              <a:defRPr sz="3200" b="1">
+              <a:defRPr sz="3000" b="1">
                 <a:solidFill>
                   <a:srgbClr val="10B981"/>
                 </a:solidFill>
@@ -6142,7 +7158,7 @@
       </p:sp>
       <p:sp>
         <p:nvSpPr>
-          <p:cNvPr id="16" name="TextBox 15"/>
+          <p:cNvPr id="19" name="TextBox 18"/>
           <p:cNvSpPr txBox="1"/>
           <p:nvPr/>
         </p:nvSpPr>
@@ -6165,7 +7181,7 @@
             <a:pPr>
               <a:defRPr sz="1900" b="1">
                 <a:solidFill>
-                  <a:srgbClr val="1A2E26"/>
+                  <a:srgbClr val="141E18"/>
                 </a:solidFill>
                 <a:latin typeface="Malgun Gothic"/>
               </a:defRPr>
@@ -6178,7 +7194,7 @@
       </p:sp>
       <p:sp>
         <p:nvSpPr>
-          <p:cNvPr id="17" name="TextBox 16"/>
+          <p:cNvPr id="20" name="TextBox 19"/>
           <p:cNvSpPr txBox="1"/>
           <p:nvPr/>
         </p:nvSpPr>
@@ -6201,7 +7217,7 @@
             <a:pPr>
               <a:defRPr sz="1400">
                 <a:solidFill>
-                  <a:srgbClr val="5A665B"/>
+                  <a:srgbClr val="556258"/>
                 </a:solidFill>
                 <a:latin typeface="Malgun Gothic"/>
               </a:defRPr>
@@ -6245,7 +7261,7 @@
             <a:avLst/>
           </a:prstGeom>
           <a:solidFill>
-            <a:srgbClr val="F8F6F0"/>
+            <a:srgbClr val="F6F8F5"/>
           </a:solidFill>
           <a:ln>
             <a:noFill/>
@@ -6275,128 +7291,20 @@
       </p:sp>
       <p:sp>
         <p:nvSpPr>
-          <p:cNvPr id="3" name="TextBox 2"/>
-          <p:cNvSpPr txBox="1"/>
+          <p:cNvPr id="3" name="Rounded Rectangle 2"/>
+          <p:cNvSpPr/>
           <p:nvPr/>
         </p:nvSpPr>
         <p:spPr>
           <a:xfrm>
             <a:off x="731520" y="365760"/>
-            <a:ext cx="1828800" cy="365760"/>
-          </a:xfrm>
-          <a:prstGeom prst="rect">
-            <a:avLst/>
-          </a:prstGeom>
-          <a:noFill/>
-        </p:spPr>
-        <p:txBody>
-          <a:bodyPr wrap="none">
-            <a:spAutoFit/>
-          </a:bodyPr>
-          <a:lstStyle/>
-          <a:p>
-            <a:pPr>
-              <a:defRPr sz="1400" b="1">
-                <a:solidFill>
-                  <a:srgbClr val="10B981"/>
-                </a:solidFill>
-                <a:latin typeface="Outfit"/>
-              </a:defRPr>
-            </a:pPr>
-            <a:r>
-              <a:t>SLIDE 07</a:t>
-            </a:r>
-          </a:p>
-        </p:txBody>
-      </p:sp>
-      <p:sp>
-        <p:nvSpPr>
-          <p:cNvPr id="4" name="TextBox 3"/>
-          <p:cNvSpPr txBox="1"/>
-          <p:nvPr/>
-        </p:nvSpPr>
-        <p:spPr>
-          <a:xfrm>
-            <a:off x="1828800" y="365760"/>
-            <a:ext cx="9601200" cy="365760"/>
-          </a:xfrm>
-          <a:prstGeom prst="rect">
-            <a:avLst/>
-          </a:prstGeom>
-          <a:noFill/>
-        </p:spPr>
-        <p:txBody>
-          <a:bodyPr wrap="none">
-            <a:spAutoFit/>
-          </a:bodyPr>
-          <a:lstStyle/>
-          <a:p>
-            <a:pPr>
-              <a:defRPr sz="1300" b="1">
-                <a:solidFill>
-                  <a:srgbClr val="5A665B"/>
-                </a:solidFill>
-                <a:latin typeface="Malgun Gothic"/>
-              </a:defRPr>
-            </a:pPr>
-            <a:r>
-              <a:t>|  CONCLUSION &amp; ROADMAP</a:t>
-            </a:r>
-          </a:p>
-        </p:txBody>
-      </p:sp>
-      <p:sp>
-        <p:nvSpPr>
-          <p:cNvPr id="5" name="TextBox 4"/>
-          <p:cNvSpPr txBox="1"/>
-          <p:nvPr/>
-        </p:nvSpPr>
-        <p:spPr>
-          <a:xfrm>
-            <a:off x="731520" y="685800"/>
-            <a:ext cx="10698480" cy="731520"/>
-          </a:xfrm>
-          <a:prstGeom prst="rect">
-            <a:avLst/>
-          </a:prstGeom>
-          <a:noFill/>
-        </p:spPr>
-        <p:txBody>
-          <a:bodyPr wrap="square">
-            <a:spAutoFit/>
-          </a:bodyPr>
-          <a:lstStyle/>
-          <a:p>
-            <a:pPr>
-              <a:defRPr sz="2500" b="1">
-                <a:solidFill>
-                  <a:srgbClr val="1A2E26"/>
-                </a:solidFill>
-                <a:latin typeface="Malgun Gothic"/>
-              </a:defRPr>
-            </a:pPr>
-            <a:r>
-              <a:t>프로젝트 결론 및 향후 발전 로드맵</a:t>
-            </a:r>
-          </a:p>
-        </p:txBody>
-      </p:sp>
-      <p:sp>
-        <p:nvSpPr>
-          <p:cNvPr id="6" name="Rounded Rectangle 5"/>
-          <p:cNvSpPr/>
-          <p:nvPr/>
-        </p:nvSpPr>
-        <p:spPr>
-          <a:xfrm>
-            <a:off x="731520" y="1645920"/>
-            <a:ext cx="10728655" cy="4572000"/>
+            <a:ext cx="109728" cy="822960"/>
           </a:xfrm>
           <a:prstGeom prst="roundRect">
             <a:avLst/>
           </a:prstGeom>
           <a:solidFill>
-            <a:srgbClr val="1A2E26"/>
+            <a:srgbClr val="10B981"/>
           </a:solidFill>
           <a:ln>
             <a:noFill/>
@@ -6426,14 +7334,50 @@
       </p:sp>
       <p:sp>
         <p:nvSpPr>
-          <p:cNvPr id="7" name="TextBox 6"/>
+          <p:cNvPr id="4" name="TextBox 3"/>
           <p:cNvSpPr txBox="1"/>
           <p:nvPr/>
         </p:nvSpPr>
         <p:spPr>
           <a:xfrm>
-            <a:off x="1097280" y="2011680"/>
-            <a:ext cx="9966960" cy="3840480"/>
+            <a:off x="960120" y="320040"/>
+            <a:ext cx="10424160" cy="320040"/>
+          </a:xfrm>
+          <a:prstGeom prst="rect">
+            <a:avLst/>
+          </a:prstGeom>
+          <a:noFill/>
+        </p:spPr>
+        <p:txBody>
+          <a:bodyPr wrap="none">
+            <a:spAutoFit/>
+          </a:bodyPr>
+          <a:lstStyle/>
+          <a:p>
+            <a:pPr>
+              <a:defRPr sz="1300" b="1">
+                <a:solidFill>
+                  <a:srgbClr val="10B981"/>
+                </a:solidFill>
+                <a:latin typeface="Outfit"/>
+              </a:defRPr>
+            </a:pPr>
+            <a:r>
+              <a:t>SLIDE 07  |  CONCLUSION &amp; ROADMAP</a:t>
+            </a:r>
+          </a:p>
+        </p:txBody>
+      </p:sp>
+      <p:sp>
+        <p:nvSpPr>
+          <p:cNvPr id="5" name="TextBox 4"/>
+          <p:cNvSpPr txBox="1"/>
+          <p:nvPr/>
+        </p:nvSpPr>
+        <p:spPr>
+          <a:xfrm>
+            <a:off x="960120" y="621792"/>
+            <a:ext cx="10424160" cy="640080"/>
           </a:xfrm>
           <a:prstGeom prst="rect">
             <a:avLst/>
@@ -6447,6 +7391,87 @@
           <a:lstStyle/>
           <a:p>
             <a:pPr>
+              <a:defRPr sz="2400" b="1">
+                <a:solidFill>
+                  <a:srgbClr val="141E18"/>
+                </a:solidFill>
+                <a:latin typeface="Malgun Gothic"/>
+              </a:defRPr>
+            </a:pPr>
+            <a:r>
+              <a:t>프로젝트 최종 결론 및 향후 발전 로드맵</a:t>
+            </a:r>
+          </a:p>
+        </p:txBody>
+      </p:sp>
+      <p:sp>
+        <p:nvSpPr>
+          <p:cNvPr id="6" name="Rounded Rectangle 5"/>
+          <p:cNvSpPr/>
+          <p:nvPr/>
+        </p:nvSpPr>
+        <p:spPr>
+          <a:xfrm>
+            <a:off x="731520" y="1463040"/>
+            <a:ext cx="10728655" cy="4754880"/>
+          </a:xfrm>
+          <a:prstGeom prst="roundRect">
+            <a:avLst/>
+          </a:prstGeom>
+          <a:solidFill>
+            <a:srgbClr val="13221B"/>
+          </a:solidFill>
+          <a:ln w="19050">
+            <a:solidFill>
+              <a:srgbClr val="264034"/>
+            </a:solidFill>
+          </a:ln>
+        </p:spPr>
+        <p:style>
+          <a:lnRef idx="1">
+            <a:schemeClr val="accent1"/>
+          </a:lnRef>
+          <a:fillRef idx="3">
+            <a:schemeClr val="accent1"/>
+          </a:fillRef>
+          <a:effectRef idx="2">
+            <a:schemeClr val="accent1"/>
+          </a:effectRef>
+          <a:fontRef idx="minor">
+            <a:schemeClr val="lt1"/>
+          </a:fontRef>
+        </p:style>
+        <p:txBody>
+          <a:bodyPr rtlCol="0" anchor="ctr"/>
+          <a:lstStyle/>
+          <a:p>
+            <a:pPr algn="ctr"/>
+          </a:p>
+        </p:txBody>
+      </p:sp>
+      <p:sp>
+        <p:nvSpPr>
+          <p:cNvPr id="7" name="TextBox 6"/>
+          <p:cNvSpPr txBox="1"/>
+          <p:nvPr/>
+        </p:nvSpPr>
+        <p:spPr>
+          <a:xfrm>
+            <a:off x="1097280" y="1737360"/>
+            <a:ext cx="9966960" cy="4206240"/>
+          </a:xfrm>
+          <a:prstGeom prst="rect">
+            <a:avLst/>
+          </a:prstGeom>
+          <a:noFill/>
+        </p:spPr>
+        <p:txBody>
+          <a:bodyPr wrap="square">
+            <a:spAutoFit/>
+          </a:bodyPr>
+          <a:lstStyle/>
+          <a:p>
+            <a:pPr>
               <a:defRPr sz="2200" b="1">
                 <a:solidFill>
                   <a:srgbClr val="10B981"/>
@@ -6461,9 +7486,9 @@
           <a:p>
             <a:pPr>
               <a:spcBef>
-                <a:spcPts val="1000"/>
+                <a:spcPts val="800"/>
               </a:spcBef>
-              <a:defRPr sz="1600">
+              <a:defRPr sz="1500">
                 <a:solidFill>
                   <a:srgbClr val="FFFFFF"/>
                 </a:solidFill>
@@ -6477,9 +7502,9 @@
           <a:p>
             <a:pPr>
               <a:spcBef>
-                <a:spcPts val="1000"/>
+                <a:spcPts val="800"/>
               </a:spcBef>
-              <a:defRPr sz="1600">
+              <a:defRPr sz="1500">
                 <a:solidFill>
                   <a:srgbClr val="FFFFFF"/>
                 </a:solidFill>
@@ -6487,15 +7512,15 @@
               </a:defRPr>
             </a:pPr>
             <a:r>
-              <a:t>2. 별도 기술이나 연공 없이 몇 번의 클릭으로 제작 가능한 사용자 친화적 UI/UX를 구현하였습니다.</a:t>
+              <a:t>2. 별도 편집 기술 없이 몇 번의 클릭으로 제작 가능한 사용자 친화적 웹 UI/UX 시스템을 구현하였습니다.</a:t>
             </a:r>
           </a:p>
           <a:p>
             <a:pPr>
               <a:spcBef>
-                <a:spcPts val="1000"/>
+                <a:spcPts val="800"/>
               </a:spcBef>
-              <a:defRPr sz="1600">
+              <a:defRPr sz="1500">
                 <a:solidFill>
                   <a:srgbClr val="FFFFFF"/>
                 </a:solidFill>
@@ -6509,9 +7534,9 @@
           <a:p>
             <a:pPr>
               <a:spcBef>
-                <a:spcPts val="1000"/>
+                <a:spcPts val="800"/>
               </a:spcBef>
-              <a:defRPr sz="1600">
+              <a:defRPr sz="1500">
                 <a:solidFill>
                   <a:srgbClr val="FFFFFF"/>
                 </a:solidFill>
@@ -6525,9 +7550,9 @@
           <a:p>
             <a:pPr>
               <a:spcBef>
-                <a:spcPts val="1000"/>
+                <a:spcPts val="800"/>
               </a:spcBef>
-              <a:defRPr sz="1600">
+              <a:defRPr sz="1500">
                 <a:solidFill>
                   <a:srgbClr val="FFFFFF"/>
                 </a:solidFill>
@@ -6541,9 +7566,9 @@
           <a:p>
             <a:pPr>
               <a:spcBef>
-                <a:spcPts val="1000"/>
+                <a:spcPts val="800"/>
               </a:spcBef>
-              <a:defRPr sz="1600">
+              <a:defRPr sz="1500">
                 <a:solidFill>
                   <a:srgbClr val="FFFFFF"/>
                 </a:solidFill>

</xml_diff>

<commit_message>
Update PPT presentation with active clickable hyperlink and live demo buttons
</commit_message>
<xml_diff>
--- a/GBAN_AI_숏폼_스튜디오_발표자료_7장.pptx
+++ b/GBAN_AI_숏폼_스튜디오_발표자료_7장.pptx
@@ -3392,8 +3392,8 @@
         </p:nvSpPr>
         <p:spPr>
           <a:xfrm>
-            <a:off x="1371600" y="4800600"/>
-            <a:ext cx="9418320" cy="731520"/>
+            <a:off x="1371600" y="4754880"/>
+            <a:ext cx="5943600" cy="822960"/>
           </a:xfrm>
           <a:prstGeom prst="rect">
             <a:avLst/>
@@ -3407,7 +3407,7 @@
           <a:lstStyle/>
           <a:p>
             <a:pPr>
-              <a:defRPr sz="1600" b="1">
+              <a:defRPr sz="1500" b="1">
                 <a:solidFill>
                   <a:srgbClr val="FFFFFF"/>
                 </a:solidFill>
@@ -3417,9 +3417,85 @@
             <a:r>
               <a:t>• 발표팀: 팀 3 (이동은, 김영아, 이미향)</a:t>
             </a:r>
-            <a:br/>
-            <a:r>
-              <a:t>• 라이브 서비스 주소: https://gban-shorts.onrender.com</a:t>
+          </a:p>
+          <a:p>
+            <a:pPr>
+              <a:defRPr sz="1500" b="1">
+                <a:solidFill>
+                  <a:srgbClr val="FFFFFF"/>
+                </a:solidFill>
+                <a:latin typeface="Malgun Gothic"/>
+              </a:defRPr>
+            </a:pPr>
+            <a:r>
+              <a:t>• 라이브 서비스 주소: </a:t>
+            </a:r>
+            <a:r>
+              <a:rPr sz="1500" b="1" u="sng">
+                <a:solidFill>
+                  <a:srgbClr val="34D399"/>
+                </a:solidFill>
+                <a:latin typeface="Malgun Gothic"/>
+                <a:hlinkClick r:id="rId2"/>
+              </a:rPr>
+              <a:t>https://gban-shorts.onrender.com</a:t>
+            </a:r>
+          </a:p>
+        </p:txBody>
+      </p:sp>
+      <p:sp>
+        <p:nvSpPr>
+          <p:cNvPr id="10" name="Rounded Rectangle 9">
+            <a:hlinkClick r:id="rId2"/>
+          </p:cNvPr>
+          <p:cNvSpPr/>
+          <p:nvPr/>
+        </p:nvSpPr>
+        <p:spPr>
+          <a:xfrm>
+            <a:off x="7589520" y="4892040"/>
+            <a:ext cx="3108960" cy="548640"/>
+          </a:xfrm>
+          <a:prstGeom prst="roundRect">
+            <a:avLst/>
+          </a:prstGeom>
+          <a:solidFill>
+            <a:srgbClr val="10B981"/>
+          </a:solidFill>
+          <a:ln>
+            <a:solidFill>
+              <a:srgbClr val="34D399"/>
+            </a:solidFill>
+          </a:ln>
+        </p:spPr>
+        <p:style>
+          <a:lnRef idx="1">
+            <a:schemeClr val="accent1"/>
+          </a:lnRef>
+          <a:fillRef idx="3">
+            <a:schemeClr val="accent1"/>
+          </a:fillRef>
+          <a:effectRef idx="2">
+            <a:schemeClr val="accent1"/>
+          </a:effectRef>
+          <a:fontRef idx="minor">
+            <a:schemeClr val="lt1"/>
+          </a:fontRef>
+        </p:style>
+        <p:txBody>
+          <a:bodyPr rtlCol="0" anchor="ctr"/>
+          <a:lstStyle/>
+          <a:p>
+            <a:pPr algn="ctr">
+              <a:defRPr sz="1300" b="1">
+                <a:solidFill>
+                  <a:srgbClr val="FFFFFF"/>
+                </a:solidFill>
+                <a:latin typeface="Malgun Gothic"/>
+              </a:defRPr>
+            </a:pPr>
+            <a:r>
+              <a:t>🚀 라이브 스튜디오 바로가기 🔗</a:t>
             </a:r>
           </a:p>
         </p:txBody>
@@ -7577,6 +7653,63 @@
             </a:pPr>
             <a:r>
               <a:t>    • 경상북도농업기술원과 함께하는 스마트 농정 및 도민 안전 실현</a:t>
+            </a:r>
+          </a:p>
+        </p:txBody>
+      </p:sp>
+      <p:sp>
+        <p:nvSpPr>
+          <p:cNvPr id="8" name="Rounded Rectangle 7">
+            <a:hlinkClick r:id="rId2"/>
+          </p:cNvPr>
+          <p:cNvSpPr/>
+          <p:nvPr/>
+        </p:nvSpPr>
+        <p:spPr>
+          <a:xfrm>
+            <a:off x="6858000" y="5303520"/>
+            <a:ext cx="4114800" cy="640080"/>
+          </a:xfrm>
+          <a:prstGeom prst="roundRect">
+            <a:avLst/>
+          </a:prstGeom>
+          <a:solidFill>
+            <a:srgbClr val="10B981"/>
+          </a:solidFill>
+          <a:ln>
+            <a:solidFill>
+              <a:srgbClr val="34D399"/>
+            </a:solidFill>
+          </a:ln>
+        </p:spPr>
+        <p:style>
+          <a:lnRef idx="1">
+            <a:schemeClr val="accent1"/>
+          </a:lnRef>
+          <a:fillRef idx="3">
+            <a:schemeClr val="accent1"/>
+          </a:fillRef>
+          <a:effectRef idx="2">
+            <a:schemeClr val="accent1"/>
+          </a:effectRef>
+          <a:fontRef idx="minor">
+            <a:schemeClr val="lt1"/>
+          </a:fontRef>
+        </p:style>
+        <p:txBody>
+          <a:bodyPr rtlCol="0" anchor="ctr"/>
+          <a:lstStyle/>
+          <a:p>
+            <a:pPr algn="ctr">
+              <a:defRPr sz="1400" b="1">
+                <a:solidFill>
+                  <a:srgbClr val="FFFFFF"/>
+                </a:solidFill>
+                <a:latin typeface="Malgun Gothic"/>
+              </a:defRPr>
+            </a:pPr>
+            <a:r>
+              <a:t>🌐 라이브 서비스 시연 바로가기 (클릭) 🔗</a:t>
             </a:r>
           </a:p>
         </p:txBody>

</xml_diff>